<commit_message>
Teach code through line-by-line explanations
</commit_message>
<xml_diff>
--- a/blocks/A_ros2_basics/M04_tf2_frames/M04_TF2와_로봇_좌표계.pptx
+++ b/blocks/A_ros2_basics/M04_tf2_frames/M04_TF2와_로봇_좌표계.pptx
@@ -21,6 +21,8 @@
     <p:sldId id="269" r:id="rId21"/>
     <p:sldId id="270" r:id="rId22"/>
     <p:sldId id="271" r:id="rId23"/>
+    <p:sldId id="272" r:id="rId24"/>
+    <p:sldId id="273" r:id="rId25"/>
   </p:sldIdLst>
   <p:sldSz cx="12191999" cy="6858000" type="screen4x3"/>
   <p:notesSz cx="6858000" cy="9144000"/>
@@ -607,17 +609,22 @@
           <a:lstStyle/>
           <a:p>
             <a:r>
-              <a:t>[설명] build/source/run을 생략 없이 실행한다.</a:t>
-            </a:r>
-          </a:p>
-          <a:p>
-            <a:r>
-              <a:t>[실행] ros2 run tf2_ros static_transform_publisher 0.12 0 0.28 0 0 0 base_link lidar_link</a:t>
-            </a:r>
-          </a:p>
-          <a:p>
-            <a:r>
-              <a:t>[확인] 정적 TF를 발행하고 frame 이름과 RViz Fixed Frame의 관계를 설명한다.</a:t>
+              <a:t>[설명] 고정 장착 센서는 시간에 따라 바뀌지 않는 transform을 사용한다.</a:t>
+            </a:r>
+          </a:p>
+          <a:p>
+            <a:r>
+              <a:t>[실행] source /opt/ros/jazzy/setup.bash</a:t>
+            </a:r>
+          </a:p>
+          <a:p>
+            <a:r>
+              <a:t>ros2 run tf2_ros static_transform_publisher 0.12 0 0.28 0 0 0 base_link lidar_link</a:t>
+            </a:r>
+          </a:p>
+          <a:p>
+            <a:r>
+              <a:t>[확인] 명령 출력에서 슬라이드의 확인 항목을 찾는다.</a:t>
             </a:r>
           </a:p>
           <a:p>
@@ -697,17 +704,22 @@
           <a:lstStyle/>
           <a:p>
             <a:r>
-              <a:t>[설명] 실제 Ubuntu/ROS 2 환경에서 생성한 검증 화면이다.</a:t>
-            </a:r>
-          </a:p>
-          <a:p>
-            <a:r>
-              <a:t>[실행] 슬라이드의 명령 또는 파일 작성 단계를 진행한다.</a:t>
-            </a:r>
-          </a:p>
-          <a:p>
-            <a:r>
-              <a:t>[확인] ① 명령/설정  ② 정상 출력 또는 화면  ③ 다음 검증 명령으로 재확인</a:t>
+              <a:t>[설명] frame의 부모·자식과 누락 여부를 파일로 확인한다.</a:t>
+            </a:r>
+          </a:p>
+          <a:p>
+            <a:r>
+              <a:t>[실행] ros2 run tf2_tools view_frames</a:t>
+            </a:r>
+          </a:p>
+          <a:p>
+            <a:r>
+              <a:t># frames.pdf 생성 뒤 base_link → lidar_link 연결을 확인</a:t>
+            </a:r>
+          </a:p>
+          <a:p>
+            <a:r>
+              <a:t>[확인] 명령 출력에서 슬라이드의 확인 항목을 찾는다.</a:t>
             </a:r>
           </a:p>
           <a:p>
@@ -787,17 +799,12 @@
           <a:lstStyle/>
           <a:p>
             <a:r>
-              <a:t>[설명] 검증 명령은 GUI 결과와 별도로 실행해 재현 가능한 완료 기준을 만든다.</a:t>
-            </a:r>
-          </a:p>
-          <a:p>
-            <a:r>
-              <a:t>[실행] ros2 topic echo /tf_static --once</a:t>
-            </a:r>
-          </a:p>
-          <a:p>
-            <a:r>
-              <a:t>ros2 run tf2_tools view_frames</a:t>
+              <a:t>[설명] build/source/run을 생략 없이 실행한다.</a:t>
+            </a:r>
+          </a:p>
+          <a:p>
+            <a:r>
+              <a:t>[실행] ros2 run tf2_ros static_transform_publisher 0.12 0 0.28 0 0 0 base_link lidar_link</a:t>
             </a:r>
           </a:p>
           <a:p>
@@ -882,7 +889,7 @@
           <a:lstStyle/>
           <a:p>
             <a:r>
-              <a:t>[설명] 오류를 대신 해결하지 말고 증상부터 우선 확인 순서대로 교육생이 실행하게 한다.</a:t>
+              <a:t>[설명] 실제 Ubuntu/ROS 2 환경에서 생성한 검증 화면이다.</a:t>
             </a:r>
           </a:p>
           <a:p>
@@ -892,7 +899,7 @@
           </a:p>
           <a:p>
             <a:r>
-              <a:t>[확인] 수정 뒤 첫 검증 명령을 다시 실행한다.</a:t>
+              <a:t>[확인] ① 명령/설정  ② 정상 출력 또는 화면  ③ 다음 검증 명령으로 재확인</a:t>
             </a:r>
           </a:p>
           <a:p>
@@ -902,7 +909,7 @@
           </a:p>
           <a:p>
             <a:r>
-              <a:t>[오류] 슬라이드의 두 대표 오류를 먼저 사용한다.</a:t>
+              <a:t>[오류] 오류가 나면 현재 폴더, source, 파일 경로를 먼저 확인한다.</a:t>
             </a:r>
           </a:p>
         </p:txBody>
@@ -972,17 +979,22 @@
           <a:lstStyle/>
           <a:p>
             <a:r>
-              <a:t>[설명] 교육생이 직접 한 값만 바꿔 원인과 결과를 연결하게 한다.</a:t>
-            </a:r>
-          </a:p>
-          <a:p>
-            <a:r>
-              <a:t>[실행] 슬라이드의 명령 또는 파일 작성 단계를 진행한다.</a:t>
-            </a:r>
-          </a:p>
-          <a:p>
-            <a:r>
-              <a:t>[확인] 원래 값과 변경 값을 모두 기록한다.</a:t>
+              <a:t>[설명] 검증 명령은 GUI 결과와 별도로 실행해 재현 가능한 완료 기준을 만든다.</a:t>
+            </a:r>
+          </a:p>
+          <a:p>
+            <a:r>
+              <a:t>[실행] ros2 topic echo /tf_static --once</a:t>
+            </a:r>
+          </a:p>
+          <a:p>
+            <a:r>
+              <a:t>ros2 run tf2_tools view_frames</a:t>
+            </a:r>
+          </a:p>
+          <a:p>
+            <a:r>
+              <a:t>[확인] 정적 TF를 발행하고 frame 이름과 RViz Fixed Frame의 관계를 설명한다.</a:t>
             </a:r>
           </a:p>
           <a:p>
@@ -1062,7 +1074,7 @@
           <a:lstStyle/>
           <a:p>
             <a:r>
-              <a:t>[설명] 교육생이 자신의 workspace·캡처·로그를 저장했는지 확인하고 다음 모듈의 시작 상태를 읽는다.</a:t>
+              <a:t>[설명] 오류를 대신 해결하지 말고 증상부터 우선 확인 순서대로 교육생이 실행하게 한다.</a:t>
             </a:r>
           </a:p>
           <a:p>
@@ -1072,7 +1084,7 @@
           </a:p>
           <a:p>
             <a:r>
-              <a:t>[확인] M05 URDF link/joint 시작 조건을 말할 수 있다.</a:t>
+              <a:t>[확인] 수정 뒤 첫 검증 명령을 다시 실행한다.</a:t>
             </a:r>
           </a:p>
           <a:p>
@@ -1082,7 +1094,7 @@
           </a:p>
           <a:p>
             <a:r>
-              <a:t>[오류] 오류가 나면 현재 폴더, source, 파일 경로를 먼저 확인한다.</a:t>
+              <a:t>[오류] 슬라이드의 두 대표 오류를 먼저 사용한다.</a:t>
             </a:r>
           </a:p>
         </p:txBody>
@@ -1152,6 +1164,186 @@
           <a:lstStyle/>
           <a:p>
             <a:r>
+              <a:t>[설명] 교육생이 직접 한 값만 바꿔 원인과 결과를 연결하게 한다.</a:t>
+            </a:r>
+          </a:p>
+          <a:p>
+            <a:r>
+              <a:t>[실행] 슬라이드의 명령 또는 파일 작성 단계를 진행한다.</a:t>
+            </a:r>
+          </a:p>
+          <a:p>
+            <a:r>
+              <a:t>[확인] 원래 값과 변경 값을 모두 기록한다.</a:t>
+            </a:r>
+          </a:p>
+          <a:p>
+            <a:r>
+              <a:t>[멈춤] 교육생이 현재 체크포인트를 통과할 때까지 기다린다.</a:t>
+            </a:r>
+          </a:p>
+          <a:p>
+            <a:r>
+              <a:t>[오류] 오류가 나면 현재 폴더, source, 파일 경로를 먼저 확인한다.</a:t>
+            </a:r>
+          </a:p>
+        </p:txBody>
+      </p:sp>
+      <p:sp>
+        <p:nvSpPr>
+          <p:cNvPr id="4" name="Slide Number Placeholder 3"/>
+          <p:cNvSpPr>
+            <a:spLocks noGrp="1"/>
+          </p:cNvSpPr>
+          <p:nvPr>
+            <p:ph type="sldNum" idx="5" sz="quarter"/>
+          </p:nvPr>
+        </p:nvSpPr>
+        <p:spPr/>
+      </p:sp>
+    </p:spTree>
+  </p:cSld>
+  <p:clrMapOvr>
+    <a:masterClrMapping/>
+  </p:clrMapOvr>
+</p:notes>
+</file>
+
+<file path=ppt/notesSlides/notesSlide17.xml><?xml version="1.0" encoding="utf-8"?>
+<p:notes xmlns:a="http://schemas.openxmlformats.org/drawingml/2006/main" xmlns:p="http://schemas.openxmlformats.org/presentationml/2006/main" xmlns:r="http://schemas.openxmlformats.org/officeDocument/2006/relationships">
+  <p:cSld>
+    <p:spTree>
+      <p:nvGrpSpPr>
+        <p:cNvPr id="1" name=""/>
+        <p:cNvGrpSpPr/>
+        <p:nvPr/>
+      </p:nvGrpSpPr>
+      <p:grpSpPr>
+        <a:xfrm>
+          <a:off x="0" y="0"/>
+          <a:ext cx="0" cy="0"/>
+          <a:chOff x="0" y="0"/>
+          <a:chExt cx="0" cy="0"/>
+        </a:xfrm>
+      </p:grpSpPr>
+      <p:sp>
+        <p:nvSpPr>
+          <p:cNvPr id="2" name="Slide Image Placeholder 1"/>
+          <p:cNvSpPr>
+            <a:spLocks noGrp="1"/>
+          </p:cNvSpPr>
+          <p:nvPr>
+            <p:ph type="sldImg" idx="2"/>
+          </p:nvPr>
+        </p:nvSpPr>
+        <p:spPr/>
+      </p:sp>
+      <p:sp>
+        <p:nvSpPr>
+          <p:cNvPr id="3" name="Notes Placeholder 2"/>
+          <p:cNvSpPr>
+            <a:spLocks noGrp="1"/>
+          </p:cNvSpPr>
+          <p:nvPr>
+            <p:ph type="body" idx="3" sz="quarter"/>
+          </p:nvPr>
+        </p:nvSpPr>
+        <p:spPr/>
+        <p:txBody>
+          <a:bodyPr/>
+          <a:lstStyle/>
+          <a:p>
+            <a:r>
+              <a:t>[설명] 교육생이 자신의 workspace·캡처·로그를 저장했는지 확인하고 다음 모듈의 시작 상태를 읽는다.</a:t>
+            </a:r>
+          </a:p>
+          <a:p>
+            <a:r>
+              <a:t>[실행] 슬라이드의 명령 또는 파일 작성 단계를 진행한다.</a:t>
+            </a:r>
+          </a:p>
+          <a:p>
+            <a:r>
+              <a:t>[확인] M05 URDF link/joint 시작 조건을 말할 수 있다.</a:t>
+            </a:r>
+          </a:p>
+          <a:p>
+            <a:r>
+              <a:t>[멈춤] 교육생이 현재 체크포인트를 통과할 때까지 기다린다.</a:t>
+            </a:r>
+          </a:p>
+          <a:p>
+            <a:r>
+              <a:t>[오류] 오류가 나면 현재 폴더, source, 파일 경로를 먼저 확인한다.</a:t>
+            </a:r>
+          </a:p>
+        </p:txBody>
+      </p:sp>
+      <p:sp>
+        <p:nvSpPr>
+          <p:cNvPr id="4" name="Slide Number Placeholder 3"/>
+          <p:cNvSpPr>
+            <a:spLocks noGrp="1"/>
+          </p:cNvSpPr>
+          <p:nvPr>
+            <p:ph type="sldNum" idx="5" sz="quarter"/>
+          </p:nvPr>
+        </p:nvSpPr>
+        <p:spPr/>
+      </p:sp>
+    </p:spTree>
+  </p:cSld>
+  <p:clrMapOvr>
+    <a:masterClrMapping/>
+  </p:clrMapOvr>
+</p:notes>
+</file>
+
+<file path=ppt/notesSlides/notesSlide18.xml><?xml version="1.0" encoding="utf-8"?>
+<p:notes xmlns:a="http://schemas.openxmlformats.org/drawingml/2006/main" xmlns:p="http://schemas.openxmlformats.org/presentationml/2006/main" xmlns:r="http://schemas.openxmlformats.org/officeDocument/2006/relationships">
+  <p:cSld>
+    <p:spTree>
+      <p:nvGrpSpPr>
+        <p:cNvPr id="1" name=""/>
+        <p:cNvGrpSpPr/>
+        <p:nvPr/>
+      </p:nvGrpSpPr>
+      <p:grpSpPr>
+        <a:xfrm>
+          <a:off x="0" y="0"/>
+          <a:ext cx="0" cy="0"/>
+          <a:chOff x="0" y="0"/>
+          <a:chExt cx="0" cy="0"/>
+        </a:xfrm>
+      </p:grpSpPr>
+      <p:sp>
+        <p:nvSpPr>
+          <p:cNvPr id="2" name="Slide Image Placeholder 1"/>
+          <p:cNvSpPr>
+            <a:spLocks noGrp="1"/>
+          </p:cNvSpPr>
+          <p:nvPr>
+            <p:ph type="sldImg" idx="2"/>
+          </p:nvPr>
+        </p:nvSpPr>
+        <p:spPr/>
+      </p:sp>
+      <p:sp>
+        <p:nvSpPr>
+          <p:cNvPr id="3" name="Notes Placeholder 2"/>
+          <p:cNvSpPr>
+            <a:spLocks noGrp="1"/>
+          </p:cNvSpPr>
+          <p:nvPr>
+            <p:ph type="body" idx="3" sz="quarter"/>
+          </p:nvPr>
+        </p:nvSpPr>
+        <p:spPr/>
+        <p:txBody>
+          <a:bodyPr/>
+          <a:lstStyle/>
+          <a:p>
+            <a:r>
               <a:t>[설명] 공식 문서는 버전 차이와 확장 학습을 확인할 때 사용한다.</a:t>
             </a:r>
           </a:p>
@@ -1782,22 +1974,17 @@
           <a:lstStyle/>
           <a:p>
             <a:r>
-              <a:t>[설명] 고정 장착 센서는 시간에 따라 바뀌지 않는 transform을 사용한다.</a:t>
-            </a:r>
-          </a:p>
-          <a:p>
-            <a:r>
-              <a:t>[실행] source /opt/ros/jazzy/setup.bash</a:t>
-            </a:r>
-          </a:p>
-          <a:p>
-            <a:r>
-              <a:t>ros2 run tf2_ros static_transform_publisher 0.12 0 0.28 0 0 0 base_link lidar_link</a:t>
-            </a:r>
-          </a:p>
-          <a:p>
-            <a:r>
-              <a:t>[확인] 명령 출력에서 슬라이드의 확인 항목을 찾는다.</a:t>
+              <a:t>[설명] 파일 구현이 없는 모듈에서도 명령의 역할과 관찰 결과를 코드 설명처럼 연결한다.</a:t>
+            </a:r>
+          </a:p>
+          <a:p>
+            <a:r>
+              <a:t>[실행] 슬라이드의 명령 또는 파일 작성 단계를 진행한다.</a:t>
+            </a:r>
+          </a:p>
+          <a:p>
+            <a:r>
+              <a:t>[확인] 정적 TF를 발행하고 frame 이름과 RViz Fixed Frame의 관계를 설명한다.</a:t>
             </a:r>
           </a:p>
           <a:p>
@@ -1877,22 +2064,17 @@
           <a:lstStyle/>
           <a:p>
             <a:r>
-              <a:t>[설명] frame의 부모·자식과 누락 여부를 파일로 확인한다.</a:t>
-            </a:r>
-          </a:p>
-          <a:p>
-            <a:r>
-              <a:t>[실행] ros2 run tf2_tools view_frames</a:t>
-            </a:r>
-          </a:p>
-          <a:p>
-            <a:r>
-              <a:t># frames.pdf 생성 뒤 base_link → lidar_link 연결을 확인</a:t>
-            </a:r>
-          </a:p>
-          <a:p>
-            <a:r>
-              <a:t>[확인] 명령 출력에서 슬라이드의 확인 항목을 찾는다.</a:t>
+              <a:t>[설명] 파일 구현이 없는 모듈에서도 명령의 역할과 관찰 결과를 코드 설명처럼 연결한다.</a:t>
+            </a:r>
+          </a:p>
+          <a:p>
+            <a:r>
+              <a:t>[실행] 슬라이드의 명령 또는 파일 작성 단계를 진행한다.</a:t>
+            </a:r>
+          </a:p>
+          <a:p>
+            <a:r>
+              <a:t>[확인] 정적 TF를 발행하고 frame 이름과 RViz Fixed Frame의 관계를 설명한다.</a:t>
             </a:r>
           </a:p>
           <a:p>
@@ -5275,7 +5457,7 @@
               </a:defRPr>
             </a:pPr>
             <a:r>
-              <a:t>build → source → run 순서로 실행한다</a:t>
+              <a:t>구현 뒤 실행 1/2: 정적 TF를 발행한다</a:t>
             </a:r>
           </a:p>
         </p:txBody>
@@ -5314,7 +5496,7 @@
               </a:defRPr>
             </a:pPr>
             <a:r>
-              <a:t>새 파일 또는 수정 파일은 build와 source 뒤에만 실행 이름·설정에 반영됩니다.</a:t>
+              <a:t>방금 직접 만든 파일을 실행·검사하며 다음 파일로 넘어갈 기준을 만듭니다.</a:t>
             </a:r>
           </a:p>
         </p:txBody>
@@ -5450,21 +5632,99 @@
               </a:defRPr>
             </a:pPr>
             <a:r>
-              <a:t>현재 단계 실행    |    현재 폴더 ~/ros2_curri/my_agv_ws    |    현재 터미널</a:t>
-            </a:r>
-          </a:p>
-        </p:txBody>
-      </p:sp>
-      <p:sp>
-        <p:nvSpPr>
-          <p:cNvPr id="7" name="Rounded Rectangle 6"/>
+              <a:t>현재 단계 실행 1/2    |    현재 폴더 ~/ros2_curri/my_agv_ws    |    현재 터미널</a:t>
+            </a:r>
+          </a:p>
+        </p:txBody>
+      </p:sp>
+      <p:sp>
+        <p:nvSpPr>
+          <p:cNvPr id="7" name="TextBox 6"/>
+          <p:cNvSpPr txBox="1"/>
+          <p:nvPr/>
+        </p:nvSpPr>
+        <p:spPr>
+          <a:xfrm>
+            <a:off x="676656" y="1764792"/>
+            <a:ext cx="1828800" cy="347472"/>
+          </a:xfrm>
+          <a:prstGeom prst="rect">
+            <a:avLst/>
+          </a:prstGeom>
+          <a:noFill/>
+        </p:spPr>
+        <p:txBody>
+          <a:bodyPr wrap="square" lIns="73152" rIns="73152" tIns="36576" bIns="36576">
+            <a:spAutoFit/>
+          </a:bodyPr>
+          <a:lstStyle/>
+          <a:p>
+            <a:pPr algn="l">
+              <a:spcAft>
+                <a:spcPts val="0"/>
+              </a:spcAft>
+              <a:defRPr sz="1800" b="1">
+                <a:solidFill>
+                  <a:srgbClr val="225B9B"/>
+                </a:solidFill>
+                <a:latin typeface="Noto Sans CJK KR"/>
+              </a:defRPr>
+            </a:pPr>
+            <a:r>
+              <a:t>왜 하는가</a:t>
+            </a:r>
+          </a:p>
+        </p:txBody>
+      </p:sp>
+      <p:sp>
+        <p:nvSpPr>
+          <p:cNvPr id="8" name="TextBox 7"/>
+          <p:cNvSpPr txBox="1"/>
+          <p:nvPr/>
+        </p:nvSpPr>
+        <p:spPr>
+          <a:xfrm>
+            <a:off x="676656" y="2103120"/>
+            <a:ext cx="10789920" cy="512064"/>
+          </a:xfrm>
+          <a:prstGeom prst="rect">
+            <a:avLst/>
+          </a:prstGeom>
+          <a:noFill/>
+        </p:spPr>
+        <p:txBody>
+          <a:bodyPr wrap="square" lIns="73152" rIns="73152" tIns="36576" bIns="36576">
+            <a:spAutoFit/>
+          </a:bodyPr>
+          <a:lstStyle/>
+          <a:p>
+            <a:pPr algn="l">
+              <a:spcAft>
+                <a:spcPts val="0"/>
+              </a:spcAft>
+              <a:defRPr sz="2000" b="0">
+                <a:solidFill>
+                  <a:srgbClr val="122C4E"/>
+                </a:solidFill>
+                <a:latin typeface="Noto Sans CJK KR"/>
+              </a:defRPr>
+            </a:pPr>
+            <a:r>
+              <a:t>고정 장착 센서는 시간에 따라 바뀌지 않는 transform을 사용한다.</a:t>
+            </a:r>
+          </a:p>
+        </p:txBody>
+      </p:sp>
+      <p:sp>
+        <p:nvSpPr>
+          <p:cNvPr id="9" name="Rounded Rectangle 8"/>
           <p:cNvSpPr/>
           <p:nvPr/>
         </p:nvSpPr>
         <p:spPr>
           <a:xfrm>
-            <a:off x="658368" y="1700784"/>
-            <a:ext cx="10972800" cy="3182112"/>
+            <a:off x="676656" y="2871216"/>
+            <a:ext cx="10835640" cy="2331720"/>
           </a:xfrm>
           <a:prstGeom prst="roundRect">
             <a:avLst/>
@@ -5508,6 +5768,10 @@
               </a:defRPr>
             </a:pPr>
             <a:r>
+              <a:t>source /opt/ros/jazzy/setup.bash</a:t>
+            </a:r>
+            <a:br/>
+            <a:r>
               <a:t>ros2 run tf2_ros static_transform_publisher 0.12 0 0.28 0 0 0 base_link lidar_link</a:t>
             </a:r>
           </a:p>
@@ -5515,14 +5779,14 @@
       </p:sp>
       <p:sp>
         <p:nvSpPr>
-          <p:cNvPr id="8" name="TextBox 7"/>
+          <p:cNvPr id="10" name="TextBox 9"/>
           <p:cNvSpPr txBox="1"/>
           <p:nvPr/>
         </p:nvSpPr>
         <p:spPr>
           <a:xfrm>
-            <a:off x="786384" y="5239512"/>
-            <a:ext cx="1261872" cy="237744"/>
+            <a:off x="768096" y="5468112"/>
+            <a:ext cx="1143000" cy="256032"/>
           </a:xfrm>
           <a:prstGeom prst="rect">
             <a:avLst/>
@@ -5547,21 +5811,21 @@
               </a:defRPr>
             </a:pPr>
             <a:r>
-              <a:t>확인 기준</a:t>
-            </a:r>
-          </a:p>
-        </p:txBody>
-      </p:sp>
-      <p:sp>
-        <p:nvSpPr>
-          <p:cNvPr id="9" name="TextBox 8"/>
+              <a:t>확인</a:t>
+            </a:r>
+          </a:p>
+        </p:txBody>
+      </p:sp>
+      <p:sp>
+        <p:nvSpPr>
+          <p:cNvPr id="11" name="TextBox 10"/>
           <p:cNvSpPr txBox="1"/>
           <p:nvPr/>
         </p:nvSpPr>
         <p:spPr>
           <a:xfrm>
-            <a:off x="786384" y="5532120"/>
-            <a:ext cx="10469880" cy="420624"/>
+            <a:off x="768096" y="5742432"/>
+            <a:ext cx="10561320" cy="347472"/>
           </a:xfrm>
           <a:prstGeom prst="rect">
             <a:avLst/>
@@ -5586,7 +5850,7 @@
               </a:defRPr>
             </a:pPr>
             <a:r>
-              <a:t>정적 TF를 발행하고 frame 이름과 RViz Fixed Frame의 관계를 설명한다.</a:t>
+              <a:t>출력에서 topic·frame·파일 이름 또는 성공 메시지를 찾고, 맞지 않으면 다음 파일로 가지 않습니다.</a:t>
             </a:r>
           </a:p>
         </p:txBody>
@@ -5643,7 +5907,7 @@
               </a:defRPr>
             </a:pPr>
             <a:r>
-              <a:t>정상 결과: 실제 환경에서 확인한 출력</a:t>
+              <a:t>구현 뒤 실행 2/2: TF 연결을 검사한다</a:t>
             </a:r>
           </a:p>
         </p:txBody>
@@ -5682,7 +5946,7 @@
               </a:defRPr>
             </a:pPr>
             <a:r>
-              <a:t>실제 ROS 2 환경의 파일·패키지·구성 검증 로그</a:t>
+              <a:t>방금 직접 만든 파일을 실행·검사하며 다음 파일로 넘어갈 기준을 만듭니다.</a:t>
             </a:r>
           </a:p>
         </p:txBody>
@@ -5765,30 +6029,64 @@
           </a:p>
         </p:txBody>
       </p:sp>
-      <p:pic>
-        <p:nvPicPr>
-          <p:cNvPr id="6" name="Picture 5" descr="validation_terminal.png"/>
-          <p:cNvPicPr>
-            <a:picLocks noChangeAspect="1"/>
-          </p:cNvPicPr>
-          <p:nvPr/>
-        </p:nvPicPr>
-        <p:blipFill>
-          <a:blip r:embed="rId2"/>
-          <a:stretch>
-            <a:fillRect/>
-          </a:stretch>
-        </p:blipFill>
-        <p:spPr>
-          <a:xfrm>
-            <a:off x="790956" y="1884338"/>
-            <a:ext cx="10607040" cy="3738546"/>
-          </a:xfrm>
-          <a:prstGeom prst="rect">
-            <a:avLst/>
-          </a:prstGeom>
-        </p:spPr>
-      </p:pic>
+      <p:sp>
+        <p:nvSpPr>
+          <p:cNvPr id="6" name="Rectangle 5"/>
+          <p:cNvSpPr/>
+          <p:nvPr/>
+        </p:nvSpPr>
+        <p:spPr>
+          <a:xfrm>
+            <a:off x="566928" y="1188720"/>
+            <a:ext cx="11064240" cy="347472"/>
+          </a:xfrm>
+          <a:prstGeom prst="rect">
+            <a:avLst/>
+          </a:prstGeom>
+          <a:solidFill>
+            <a:srgbClr val="F4F7FB"/>
+          </a:solidFill>
+          <a:ln>
+            <a:solidFill>
+              <a:srgbClr val="F4F7FB"/>
+            </a:solidFill>
+          </a:ln>
+        </p:spPr>
+        <p:style>
+          <a:lnRef idx="1">
+            <a:schemeClr val="accent1"/>
+          </a:lnRef>
+          <a:fillRef idx="3">
+            <a:schemeClr val="accent1"/>
+          </a:fillRef>
+          <a:effectRef idx="2">
+            <a:schemeClr val="accent1"/>
+          </a:effectRef>
+          <a:fontRef idx="minor">
+            <a:schemeClr val="lt1"/>
+          </a:fontRef>
+        </p:style>
+        <p:txBody>
+          <a:bodyPr rtlCol="0" anchor="ctr" wrap="square" lIns="73152" rIns="73152" tIns="36576" bIns="36576"/>
+          <a:lstStyle/>
+          <a:p>
+            <a:pPr algn="l">
+              <a:spcAft>
+                <a:spcPts val="0"/>
+              </a:spcAft>
+              <a:defRPr sz="1300" b="1">
+                <a:solidFill>
+                  <a:srgbClr val="122C4E"/>
+                </a:solidFill>
+                <a:latin typeface="Noto Sans CJK KR"/>
+              </a:defRPr>
+            </a:pPr>
+            <a:r>
+              <a:t>현재 단계 실행 2/2    |    현재 폴더 ~/ros2_curri/my_agv_ws    |    현재 터미널</a:t>
+            </a:r>
+          </a:p>
+        </p:txBody>
+      </p:sp>
       <p:sp>
         <p:nvSpPr>
           <p:cNvPr id="7" name="TextBox 6"/>
@@ -5797,8 +6095,8 @@
         </p:nvSpPr>
         <p:spPr>
           <a:xfrm>
-            <a:off x="777240" y="6144768"/>
-            <a:ext cx="10607040" cy="310896"/>
+            <a:off x="676656" y="1764792"/>
+            <a:ext cx="1828800" cy="347472"/>
           </a:xfrm>
           <a:prstGeom prst="rect">
             <a:avLst/>
@@ -5811,11 +6109,151 @@
           </a:bodyPr>
           <a:lstStyle/>
           <a:p>
-            <a:pPr algn="ctr">
-              <a:spcAft>
-                <a:spcPts val="0"/>
-              </a:spcAft>
-              <a:defRPr sz="1100" b="1">
+            <a:pPr algn="l">
+              <a:spcAft>
+                <a:spcPts val="0"/>
+              </a:spcAft>
+              <a:defRPr sz="1800" b="1">
+                <a:solidFill>
+                  <a:srgbClr val="225B9B"/>
+                </a:solidFill>
+                <a:latin typeface="Noto Sans CJK KR"/>
+              </a:defRPr>
+            </a:pPr>
+            <a:r>
+              <a:t>왜 하는가</a:t>
+            </a:r>
+          </a:p>
+        </p:txBody>
+      </p:sp>
+      <p:sp>
+        <p:nvSpPr>
+          <p:cNvPr id="8" name="TextBox 7"/>
+          <p:cNvSpPr txBox="1"/>
+          <p:nvPr/>
+        </p:nvSpPr>
+        <p:spPr>
+          <a:xfrm>
+            <a:off x="676656" y="2103120"/>
+            <a:ext cx="10789920" cy="512064"/>
+          </a:xfrm>
+          <a:prstGeom prst="rect">
+            <a:avLst/>
+          </a:prstGeom>
+          <a:noFill/>
+        </p:spPr>
+        <p:txBody>
+          <a:bodyPr wrap="square" lIns="73152" rIns="73152" tIns="36576" bIns="36576">
+            <a:spAutoFit/>
+          </a:bodyPr>
+          <a:lstStyle/>
+          <a:p>
+            <a:pPr algn="l">
+              <a:spcAft>
+                <a:spcPts val="0"/>
+              </a:spcAft>
+              <a:defRPr sz="2000" b="0">
+                <a:solidFill>
+                  <a:srgbClr val="122C4E"/>
+                </a:solidFill>
+                <a:latin typeface="Noto Sans CJK KR"/>
+              </a:defRPr>
+            </a:pPr>
+            <a:r>
+              <a:t>frame의 부모·자식과 누락 여부를 파일로 확인한다.</a:t>
+            </a:r>
+          </a:p>
+        </p:txBody>
+      </p:sp>
+      <p:sp>
+        <p:nvSpPr>
+          <p:cNvPr id="9" name="Rounded Rectangle 8"/>
+          <p:cNvSpPr/>
+          <p:nvPr/>
+        </p:nvSpPr>
+        <p:spPr>
+          <a:xfrm>
+            <a:off x="676656" y="2871216"/>
+            <a:ext cx="10835640" cy="2331720"/>
+          </a:xfrm>
+          <a:prstGeom prst="roundRect">
+            <a:avLst/>
+          </a:prstGeom>
+          <a:solidFill>
+            <a:srgbClr val="1D232D"/>
+          </a:solidFill>
+          <a:ln>
+            <a:solidFill>
+              <a:srgbClr val="1D232D"/>
+            </a:solidFill>
+          </a:ln>
+        </p:spPr>
+        <p:style>
+          <a:lnRef idx="1">
+            <a:schemeClr val="accent1"/>
+          </a:lnRef>
+          <a:fillRef idx="3">
+            <a:schemeClr val="accent1"/>
+          </a:fillRef>
+          <a:effectRef idx="2">
+            <a:schemeClr val="accent1"/>
+          </a:effectRef>
+          <a:fontRef idx="minor">
+            <a:schemeClr val="lt1"/>
+          </a:fontRef>
+        </p:style>
+        <p:txBody>
+          <a:bodyPr rtlCol="0" anchor="ctr" wrap="square" lIns="73152" rIns="73152" tIns="36576" bIns="36576"/>
+          <a:lstStyle/>
+          <a:p>
+            <a:pPr algn="l">
+              <a:spcAft>
+                <a:spcPts val="0"/>
+              </a:spcAft>
+              <a:defRPr sz="1600" b="0">
+                <a:solidFill>
+                  <a:srgbClr val="FFFFFF"/>
+                </a:solidFill>
+                <a:latin typeface="DejaVu Sans Mono"/>
+              </a:defRPr>
+            </a:pPr>
+            <a:r>
+              <a:t>ros2 run tf2_tools view_frames</a:t>
+            </a:r>
+            <a:br/>
+            <a:r>
+              <a:t># frames.pdf 생성 뒤 base_link → lidar_link 연결을 확인</a:t>
+            </a:r>
+          </a:p>
+        </p:txBody>
+      </p:sp>
+      <p:sp>
+        <p:nvSpPr>
+          <p:cNvPr id="10" name="TextBox 9"/>
+          <p:cNvSpPr txBox="1"/>
+          <p:nvPr/>
+        </p:nvSpPr>
+        <p:spPr>
+          <a:xfrm>
+            <a:off x="768096" y="5468112"/>
+            <a:ext cx="1143000" cy="256032"/>
+          </a:xfrm>
+          <a:prstGeom prst="rect">
+            <a:avLst/>
+          </a:prstGeom>
+          <a:noFill/>
+        </p:spPr>
+        <p:txBody>
+          <a:bodyPr wrap="square" lIns="73152" rIns="73152" tIns="36576" bIns="36576">
+            <a:spAutoFit/>
+          </a:bodyPr>
+          <a:lstStyle/>
+          <a:p>
+            <a:pPr algn="l">
+              <a:spcAft>
+                <a:spcPts val="0"/>
+              </a:spcAft>
+              <a:defRPr sz="1800" b="1">
                 <a:solidFill>
                   <a:srgbClr val="2A8B5A"/>
                 </a:solidFill>
@@ -5823,7 +6261,46 @@
               </a:defRPr>
             </a:pPr>
             <a:r>
-              <a:t>화면에서 확인: ① 명령/설정  ② 정상 출력 또는 화면  ③ 다음 검증 명령으로 재확인</a:t>
+              <a:t>확인</a:t>
+            </a:r>
+          </a:p>
+        </p:txBody>
+      </p:sp>
+      <p:sp>
+        <p:nvSpPr>
+          <p:cNvPr id="11" name="TextBox 10"/>
+          <p:cNvSpPr txBox="1"/>
+          <p:nvPr/>
+        </p:nvSpPr>
+        <p:spPr>
+          <a:xfrm>
+            <a:off x="768096" y="5742432"/>
+            <a:ext cx="10561320" cy="347472"/>
+          </a:xfrm>
+          <a:prstGeom prst="rect">
+            <a:avLst/>
+          </a:prstGeom>
+          <a:noFill/>
+        </p:spPr>
+        <p:txBody>
+          <a:bodyPr wrap="square" lIns="73152" rIns="73152" tIns="36576" bIns="36576">
+            <a:spAutoFit/>
+          </a:bodyPr>
+          <a:lstStyle/>
+          <a:p>
+            <a:pPr algn="l">
+              <a:spcAft>
+                <a:spcPts val="0"/>
+              </a:spcAft>
+              <a:defRPr sz="1800" b="0">
+                <a:solidFill>
+                  <a:srgbClr val="122C4E"/>
+                </a:solidFill>
+                <a:latin typeface="Noto Sans CJK KR"/>
+              </a:defRPr>
+            </a:pPr>
+            <a:r>
+              <a:t>출력에서 topic·frame·파일 이름 또는 성공 메시지를 찾고, 맞지 않으면 다음 파일로 가지 않습니다.</a:t>
             </a:r>
           </a:p>
         </p:txBody>
@@ -5880,7 +6357,7 @@
               </a:defRPr>
             </a:pPr>
             <a:r>
-              <a:t>객관적 검증 명령으로 완료를 확인한다</a:t>
+              <a:t>build → source → run 순서로 실행한다</a:t>
             </a:r>
           </a:p>
         </p:txBody>
@@ -5919,7 +6396,7 @@
               </a:defRPr>
             </a:pPr>
             <a:r>
-              <a:t>화면만 보지 말고 topic·frame·파일·parameter를 다시 확인합니다.</a:t>
+              <a:t>새 파일 또는 수정 파일은 build와 source 뒤에만 실행 이름·설정에 반영됩니다.</a:t>
             </a:r>
           </a:p>
         </p:txBody>
@@ -6055,7 +6532,7 @@
               </a:defRPr>
             </a:pPr>
             <a:r>
-              <a:t>현재 단계 검증    |    현재 폴더 ~/ros2_curri/my_agv_ws    |    현재 터미널</a:t>
+              <a:t>현재 단계 실행    |    현재 폴더 ~/ros2_curri/my_agv_ws    |    현재 터미널</a:t>
             </a:r>
           </a:p>
         </p:txBody>
@@ -6068,8 +6545,8 @@
         </p:nvSpPr>
         <p:spPr>
           <a:xfrm>
-            <a:off x="658368" y="1755648"/>
-            <a:ext cx="10972800" cy="2148840"/>
+            <a:off x="658368" y="1700784"/>
+            <a:ext cx="10972800" cy="3182112"/>
           </a:xfrm>
           <a:prstGeom prst="roundRect">
             <a:avLst/>
@@ -6113,95 +6590,21 @@
               </a:defRPr>
             </a:pPr>
             <a:r>
-              <a:t>ros2 topic echo /tf_static --once</a:t>
-            </a:r>
-            <a:br/>
-            <a:r>
-              <a:t>ros2 run tf2_tools view_frames</a:t>
-            </a:r>
-          </a:p>
-        </p:txBody>
-      </p:sp>
-      <p:sp>
-        <p:nvSpPr>
-          <p:cNvPr id="8" name="Rounded Rectangle 7"/>
-          <p:cNvSpPr/>
-          <p:nvPr/>
-        </p:nvSpPr>
-        <p:spPr>
-          <a:xfrm>
-            <a:off x="658368" y="4206240"/>
-            <a:ext cx="10972800" cy="1554480"/>
-          </a:xfrm>
-          <a:prstGeom prst="roundRect">
-            <a:avLst/>
-          </a:prstGeom>
-          <a:solidFill>
-            <a:srgbClr val="F4F7FB"/>
-          </a:solidFill>
-          <a:ln>
-            <a:solidFill>
-              <a:srgbClr val="D1DFD5"/>
-            </a:solidFill>
-          </a:ln>
-        </p:spPr>
-        <p:style>
-          <a:lnRef idx="1">
-            <a:schemeClr val="accent1"/>
-          </a:lnRef>
-          <a:fillRef idx="3">
-            <a:schemeClr val="accent1"/>
-          </a:fillRef>
-          <a:effectRef idx="2">
-            <a:schemeClr val="accent1"/>
-          </a:effectRef>
-          <a:fontRef idx="minor">
-            <a:schemeClr val="lt1"/>
-          </a:fontRef>
-        </p:style>
-        <p:txBody>
-          <a:bodyPr rtlCol="0" anchor="ctr" wrap="square" lIns="73152" rIns="73152" tIns="36576" bIns="36576"/>
-          <a:lstStyle/>
-          <a:p>
-            <a:pPr algn="l">
-              <a:spcAft>
-                <a:spcPts val="0"/>
-              </a:spcAft>
-              <a:defRPr sz="1800" b="1">
-                <a:solidFill>
-                  <a:srgbClr val="2A8B5A"/>
-                </a:solidFill>
-                <a:latin typeface="Noto Sans CJK KR"/>
-              </a:defRPr>
-            </a:pPr>
-            <a:r>
-              <a:t>완료 체크</a:t>
-            </a:r>
-            <a:br/>
-            <a:r>
-              <a:t>□ 명령이 오류 없이 실행된다.</a:t>
-            </a:r>
-            <a:br/>
-            <a:r>
-              <a:t>□ 기대한 파일·topic·frame·parameter 이름이 보인다.</a:t>
-            </a:r>
-            <a:br/>
-            <a:r>
-              <a:t>□ 값의 단위와 방향을 한 문장으로 설명할 수 있다.</a:t>
-            </a:r>
-          </a:p>
-        </p:txBody>
-      </p:sp>
-      <p:sp>
-        <p:nvSpPr>
-          <p:cNvPr id="9" name="TextBox 8"/>
+              <a:t>ros2 run tf2_ros static_transform_publisher 0.12 0 0.28 0 0 0 base_link lidar_link</a:t>
+            </a:r>
+          </a:p>
+        </p:txBody>
+      </p:sp>
+      <p:sp>
+        <p:nvSpPr>
+          <p:cNvPr id="8" name="TextBox 7"/>
           <p:cNvSpPr txBox="1"/>
           <p:nvPr/>
         </p:nvSpPr>
         <p:spPr>
           <a:xfrm>
-            <a:off x="731520" y="5989320"/>
-            <a:ext cx="10789920" cy="237744"/>
+            <a:off x="786384" y="5239512"/>
+            <a:ext cx="1261872" cy="237744"/>
           </a:xfrm>
           <a:prstGeom prst="rect">
             <a:avLst/>
@@ -6218,7 +6621,46 @@
               <a:spcAft>
                 <a:spcPts val="0"/>
               </a:spcAft>
-              <a:defRPr sz="1500" b="1">
+              <a:defRPr sz="1800" b="1">
+                <a:solidFill>
+                  <a:srgbClr val="2A8B5A"/>
+                </a:solidFill>
+                <a:latin typeface="Noto Sans CJK KR"/>
+              </a:defRPr>
+            </a:pPr>
+            <a:r>
+              <a:t>확인 기준</a:t>
+            </a:r>
+          </a:p>
+        </p:txBody>
+      </p:sp>
+      <p:sp>
+        <p:nvSpPr>
+          <p:cNvPr id="9" name="TextBox 8"/>
+          <p:cNvSpPr txBox="1"/>
+          <p:nvPr/>
+        </p:nvSpPr>
+        <p:spPr>
+          <a:xfrm>
+            <a:off x="786384" y="5532120"/>
+            <a:ext cx="10469880" cy="420624"/>
+          </a:xfrm>
+          <a:prstGeom prst="rect">
+            <a:avLst/>
+          </a:prstGeom>
+          <a:noFill/>
+        </p:spPr>
+        <p:txBody>
+          <a:bodyPr wrap="square" lIns="73152" rIns="73152" tIns="36576" bIns="36576">
+            <a:spAutoFit/>
+          </a:bodyPr>
+          <a:lstStyle/>
+          <a:p>
+            <a:pPr algn="l">
+              <a:spcAft>
+                <a:spcPts val="0"/>
+              </a:spcAft>
+              <a:defRPr sz="1800" b="0">
                 <a:solidFill>
                   <a:srgbClr val="122C4E"/>
                 </a:solidFill>
@@ -6226,7 +6668,7 @@
               </a:defRPr>
             </a:pPr>
             <a:r>
-              <a:t>완료 조건: 정적 TF를 발행하고 frame 이름과 RViz Fixed Frame의 관계를 설명한다.</a:t>
+              <a:t>정적 TF를 발행하고 frame 이름과 RViz Fixed Frame의 관계를 설명한다.</a:t>
             </a:r>
           </a:p>
         </p:txBody>
@@ -6283,7 +6725,7 @@
               </a:defRPr>
             </a:pPr>
             <a:r>
-              <a:t>막히면: 증상 → 우선 확인 → 재검증</a:t>
+              <a:t>정상 결과: 실제 환경에서 확인한 출력</a:t>
             </a:r>
           </a:p>
         </p:txBody>
@@ -6322,7 +6764,7 @@
               </a:defRPr>
             </a:pPr>
             <a:r>
-              <a:t>오류 메시지를 숨기지 않고 같은 순서로 점검합니다.</a:t>
+              <a:t>실제 ROS 2 환경의 파일·패키지·구성 검증 로그</a:t>
             </a:r>
           </a:p>
         </p:txBody>
@@ -6405,119 +6847,40 @@
           </a:p>
         </p:txBody>
       </p:sp>
-      <p:sp>
-        <p:nvSpPr>
-          <p:cNvPr id="6" name="Rectangle 5"/>
-          <p:cNvSpPr/>
-          <p:nvPr/>
-        </p:nvSpPr>
-        <p:spPr>
-          <a:xfrm>
-            <a:off x="566928" y="1188720"/>
-            <a:ext cx="11064240" cy="347472"/>
-          </a:xfrm>
-          <a:prstGeom prst="rect">
-            <a:avLst/>
-          </a:prstGeom>
-          <a:solidFill>
-            <a:srgbClr val="F4F7FB"/>
-          </a:solidFill>
-          <a:ln>
-            <a:solidFill>
-              <a:srgbClr val="F4F7FB"/>
-            </a:solidFill>
-          </a:ln>
-        </p:spPr>
-        <p:style>
-          <a:lnRef idx="1">
-            <a:schemeClr val="accent1"/>
-          </a:lnRef>
-          <a:fillRef idx="3">
-            <a:schemeClr val="accent1"/>
-          </a:fillRef>
-          <a:effectRef idx="2">
-            <a:schemeClr val="accent1"/>
-          </a:effectRef>
-          <a:fontRef idx="minor">
-            <a:schemeClr val="lt1"/>
-          </a:fontRef>
-        </p:style>
-        <p:txBody>
-          <a:bodyPr rtlCol="0" anchor="ctr" wrap="square" lIns="73152" rIns="73152" tIns="36576" bIns="36576"/>
-          <a:lstStyle/>
-          <a:p>
-            <a:pPr algn="l">
-              <a:spcAft>
-                <a:spcPts val="0"/>
-              </a:spcAft>
-              <a:defRPr sz="1300" b="1">
-                <a:solidFill>
-                  <a:srgbClr val="122C4E"/>
-                </a:solidFill>
-                <a:latin typeface="Noto Sans CJK KR"/>
-              </a:defRPr>
-            </a:pPr>
-            <a:r>
-              <a:t>현재 단계 오류 대응    |    현재 폴더 ~/ros2_curri/my_agv_ws    |    현재 터미널</a:t>
-            </a:r>
-          </a:p>
-        </p:txBody>
-      </p:sp>
-      <p:sp>
-        <p:nvSpPr>
-          <p:cNvPr id="7" name="Rounded Rectangle 6"/>
-          <p:cNvSpPr/>
-          <p:nvPr/>
-        </p:nvSpPr>
-        <p:spPr>
-          <a:xfrm>
-            <a:off x="694944" y="1755648"/>
-            <a:ext cx="10972800" cy="1115568"/>
-          </a:xfrm>
-          <a:prstGeom prst="roundRect">
-            <a:avLst/>
-          </a:prstGeom>
-          <a:solidFill>
-            <a:srgbClr val="FFF7F4"/>
-          </a:solidFill>
-          <a:ln>
-            <a:solidFill>
-              <a:srgbClr val="EDBEB4"/>
-            </a:solidFill>
-          </a:ln>
-        </p:spPr>
-        <p:style>
-          <a:lnRef idx="1">
-            <a:schemeClr val="accent1"/>
-          </a:lnRef>
-          <a:fillRef idx="3">
-            <a:schemeClr val="accent1"/>
-          </a:fillRef>
-          <a:effectRef idx="2">
-            <a:schemeClr val="accent1"/>
-          </a:effectRef>
-          <a:fontRef idx="minor">
-            <a:schemeClr val="lt1"/>
-          </a:fontRef>
-        </p:style>
-        <p:txBody>
-          <a:bodyPr rtlCol="0" anchor="ctr"/>
-          <a:lstStyle/>
-          <a:p>
-            <a:pPr algn="ctr"/>
-          </a:p>
-        </p:txBody>
-      </p:sp>
-      <p:sp>
-        <p:nvSpPr>
-          <p:cNvPr id="8" name="TextBox 7"/>
+      <p:pic>
+        <p:nvPicPr>
+          <p:cNvPr id="6" name="Picture 5" descr="validation_terminal.png"/>
+          <p:cNvPicPr>
+            <a:picLocks noChangeAspect="1"/>
+          </p:cNvPicPr>
+          <p:nvPr/>
+        </p:nvPicPr>
+        <p:blipFill>
+          <a:blip r:embed="rId2"/>
+          <a:stretch>
+            <a:fillRect/>
+          </a:stretch>
+        </p:blipFill>
+        <p:spPr>
+          <a:xfrm>
+            <a:off x="790956" y="1884338"/>
+            <a:ext cx="10607040" cy="3738546"/>
+          </a:xfrm>
+          <a:prstGeom prst="rect">
+            <a:avLst/>
+          </a:prstGeom>
+        </p:spPr>
+      </p:pic>
+      <p:sp>
+        <p:nvSpPr>
+          <p:cNvPr id="7" name="TextBox 6"/>
           <p:cNvSpPr txBox="1"/>
           <p:nvPr/>
         </p:nvSpPr>
         <p:spPr>
           <a:xfrm>
-            <a:off x="896112" y="1901952"/>
-            <a:ext cx="2926080" cy="274320"/>
+            <a:off x="777240" y="6144768"/>
+            <a:ext cx="10607040" cy="310896"/>
           </a:xfrm>
           <a:prstGeom prst="rect">
             <a:avLst/>
@@ -6530,228 +6893,19 @@
           </a:bodyPr>
           <a:lstStyle/>
           <a:p>
-            <a:pPr algn="l">
-              <a:spcAft>
-                <a:spcPts val="0"/>
-              </a:spcAft>
-              <a:defRPr sz="1800" b="1">
-                <a:solidFill>
-                  <a:srgbClr val="BE3B3B"/>
-                </a:solidFill>
-                <a:latin typeface="Noto Sans CJK KR"/>
-              </a:defRPr>
-            </a:pPr>
-            <a:r>
-              <a:t>증상 1: RViz에 아무것도 안 보임</a:t>
-            </a:r>
-          </a:p>
-        </p:txBody>
-      </p:sp>
-      <p:sp>
-        <p:nvSpPr>
-          <p:cNvPr id="9" name="TextBox 8"/>
-          <p:cNvSpPr txBox="1"/>
-          <p:nvPr/>
-        </p:nvSpPr>
-        <p:spPr>
-          <a:xfrm>
-            <a:off x="3794760" y="1883664"/>
-            <a:ext cx="7543800" cy="621792"/>
-          </a:xfrm>
-          <a:prstGeom prst="rect">
-            <a:avLst/>
-          </a:prstGeom>
-          <a:noFill/>
-        </p:spPr>
-        <p:txBody>
-          <a:bodyPr wrap="square" lIns="73152" rIns="73152" tIns="36576" bIns="36576">
-            <a:spAutoFit/>
-          </a:bodyPr>
-          <a:lstStyle/>
-          <a:p>
-            <a:pPr algn="l">
-              <a:spcAft>
-                <a:spcPts val="0"/>
-              </a:spcAft>
-              <a:defRPr sz="1600" b="0">
-                <a:solidFill>
-                  <a:srgbClr val="122C4E"/>
-                </a:solidFill>
-                <a:latin typeface="Noto Sans CJK KR"/>
-              </a:defRPr>
-            </a:pPr>
-            <a:r>
-              <a:t>우선 확인: Fixed Frame과 TF 존재 여부를 먼저 확인한다.</a:t>
-            </a:r>
-            <a:br/>
-            <a:r>
-              <a:t>수정 후: ros2 topic echo /tf_static --once</a:t>
-            </a:r>
-          </a:p>
-        </p:txBody>
-      </p:sp>
-      <p:sp>
-        <p:nvSpPr>
-          <p:cNvPr id="10" name="Rounded Rectangle 9"/>
-          <p:cNvSpPr/>
-          <p:nvPr/>
-        </p:nvSpPr>
-        <p:spPr>
-          <a:xfrm>
-            <a:off x="694944" y="3172968"/>
-            <a:ext cx="10972800" cy="1115568"/>
-          </a:xfrm>
-          <a:prstGeom prst="roundRect">
-            <a:avLst/>
-          </a:prstGeom>
-          <a:solidFill>
-            <a:srgbClr val="FFF7F4"/>
-          </a:solidFill>
-          <a:ln>
-            <a:solidFill>
-              <a:srgbClr val="EDBEB4"/>
-            </a:solidFill>
-          </a:ln>
-        </p:spPr>
-        <p:style>
-          <a:lnRef idx="1">
-            <a:schemeClr val="accent1"/>
-          </a:lnRef>
-          <a:fillRef idx="3">
-            <a:schemeClr val="accent1"/>
-          </a:fillRef>
-          <a:effectRef idx="2">
-            <a:schemeClr val="accent1"/>
-          </a:effectRef>
-          <a:fontRef idx="minor">
-            <a:schemeClr val="lt1"/>
-          </a:fontRef>
-        </p:style>
-        <p:txBody>
-          <a:bodyPr rtlCol="0" anchor="ctr"/>
-          <a:lstStyle/>
-          <a:p>
-            <a:pPr algn="ctr"/>
-          </a:p>
-        </p:txBody>
-      </p:sp>
-      <p:sp>
-        <p:nvSpPr>
-          <p:cNvPr id="11" name="TextBox 10"/>
-          <p:cNvSpPr txBox="1"/>
-          <p:nvPr/>
-        </p:nvSpPr>
-        <p:spPr>
-          <a:xfrm>
-            <a:off x="896112" y="3319272"/>
-            <a:ext cx="2926080" cy="274320"/>
-          </a:xfrm>
-          <a:prstGeom prst="rect">
-            <a:avLst/>
-          </a:prstGeom>
-          <a:noFill/>
-        </p:spPr>
-        <p:txBody>
-          <a:bodyPr wrap="square" lIns="73152" rIns="73152" tIns="36576" bIns="36576">
-            <a:spAutoFit/>
-          </a:bodyPr>
-          <a:lstStyle/>
-          <a:p>
-            <a:pPr algn="l">
-              <a:spcAft>
-                <a:spcPts val="0"/>
-              </a:spcAft>
-              <a:defRPr sz="1800" b="1">
-                <a:solidFill>
-                  <a:srgbClr val="BE3B3B"/>
-                </a:solidFill>
-                <a:latin typeface="Noto Sans CJK KR"/>
-              </a:defRPr>
-            </a:pPr>
-            <a:r>
-              <a:t>증상 2: 센서가 엉뚱한 방향</a:t>
-            </a:r>
-          </a:p>
-        </p:txBody>
-      </p:sp>
-      <p:sp>
-        <p:nvSpPr>
-          <p:cNvPr id="12" name="TextBox 11"/>
-          <p:cNvSpPr txBox="1"/>
-          <p:nvPr/>
-        </p:nvSpPr>
-        <p:spPr>
-          <a:xfrm>
-            <a:off x="3794760" y="3300984"/>
-            <a:ext cx="7543800" cy="621792"/>
-          </a:xfrm>
-          <a:prstGeom prst="rect">
-            <a:avLst/>
-          </a:prstGeom>
-          <a:noFill/>
-        </p:spPr>
-        <p:txBody>
-          <a:bodyPr wrap="square" lIns="73152" rIns="73152" tIns="36576" bIns="36576">
-            <a:spAutoFit/>
-          </a:bodyPr>
-          <a:lstStyle/>
-          <a:p>
-            <a:pPr algn="l">
-              <a:spcAft>
-                <a:spcPts val="0"/>
-              </a:spcAft>
-              <a:defRPr sz="1600" b="0">
-                <a:solidFill>
-                  <a:srgbClr val="122C4E"/>
-                </a:solidFill>
-                <a:latin typeface="Noto Sans CJK KR"/>
-              </a:defRPr>
-            </a:pPr>
-            <a:r>
-              <a:t>우선 확인: rpy 단위·parent/child 순서·축 방향을 점검한다.</a:t>
-            </a:r>
-            <a:br/>
-            <a:r>
-              <a:t>수정 후: ros2 topic echo /tf_static --once</a:t>
-            </a:r>
-          </a:p>
-        </p:txBody>
-      </p:sp>
-      <p:sp>
-        <p:nvSpPr>
-          <p:cNvPr id="13" name="TextBox 12"/>
-          <p:cNvSpPr txBox="1"/>
-          <p:nvPr/>
-        </p:nvSpPr>
-        <p:spPr>
-          <a:xfrm>
-            <a:off x="822960" y="5102352"/>
-            <a:ext cx="10607040" cy="402336"/>
-          </a:xfrm>
-          <a:prstGeom prst="rect">
-            <a:avLst/>
-          </a:prstGeom>
-          <a:noFill/>
-        </p:spPr>
-        <p:txBody>
-          <a:bodyPr wrap="square" lIns="73152" rIns="73152" tIns="36576" bIns="36576">
-            <a:spAutoFit/>
-          </a:bodyPr>
-          <a:lstStyle/>
-          <a:p>
             <a:pPr algn="ctr">
               <a:spcAft>
                 <a:spcPts val="0"/>
               </a:spcAft>
-              <a:defRPr sz="1800" b="1">
-                <a:solidFill>
-                  <a:srgbClr val="DB7E22"/>
-                </a:solidFill>
-                <a:latin typeface="Noto Sans CJK KR"/>
-              </a:defRPr>
-            </a:pPr>
-            <a:r>
-              <a:t>공통 순서: ① 현재 폴더 ② source ③ 파일 경로 ④ 이름/타입/단위 ⑤ build·source 후 재실행</a:t>
+              <a:defRPr sz="1100" b="1">
+                <a:solidFill>
+                  <a:srgbClr val="2A8B5A"/>
+                </a:solidFill>
+                <a:latin typeface="Noto Sans CJK KR"/>
+              </a:defRPr>
+            </a:pPr>
+            <a:r>
+              <a:t>화면에서 확인: ① 명령/설정  ② 정상 출력 또는 화면  ③ 다음 검증 명령으로 재확인</a:t>
             </a:r>
           </a:p>
         </p:txBody>
@@ -6808,7 +6962,7 @@
               </a:defRPr>
             </a:pPr>
             <a:r>
-              <a:t>미니 실습: 값 하나를 바꾸고 결과를 비교한다</a:t>
+              <a:t>객관적 검증 명령으로 완료를 확인한다</a:t>
             </a:r>
           </a:p>
         </p:txBody>
@@ -6847,7 +7001,7 @@
               </a:defRPr>
             </a:pPr>
             <a:r>
-              <a:t>정상 결과를 만든 뒤에는 한 번에 하나의 값만 바꿉니다.</a:t>
+              <a:t>화면만 보지 말고 topic·frame·파일·parameter를 다시 확인합니다.</a:t>
             </a:r>
           </a:p>
         </p:txBody>
@@ -6983,7 +7137,7 @@
               </a:defRPr>
             </a:pPr>
             <a:r>
-              <a:t>현재 단계 미니 실습    |    현재 폴더 ~/ros2_curri/my_agv_ws    |    현재 터미널</a:t>
+              <a:t>현재 단계 검증    |    현재 폴더 ~/ros2_curri/my_agv_ws    |    현재 터미널</a:t>
             </a:r>
           </a:p>
         </p:txBody>
@@ -6996,18 +7150,18 @@
         </p:nvSpPr>
         <p:spPr>
           <a:xfrm>
-            <a:off x="749808" y="1874519"/>
-            <a:ext cx="10652760" cy="1993392"/>
+            <a:off x="658368" y="1755648"/>
+            <a:ext cx="10972800" cy="2148840"/>
           </a:xfrm>
           <a:prstGeom prst="roundRect">
             <a:avLst/>
           </a:prstGeom>
           <a:solidFill>
-            <a:srgbClr val="FFF8EB"/>
+            <a:srgbClr val="1D232D"/>
           </a:solidFill>
           <a:ln>
             <a:solidFill>
-              <a:srgbClr val="ECC680"/>
+              <a:srgbClr val="1D232D"/>
             </a:solidFill>
           </a:ln>
         </p:spPr>
@@ -7029,33 +7183,107 @@
           <a:bodyPr rtlCol="0" anchor="ctr" wrap="square" lIns="73152" rIns="73152" tIns="36576" bIns="36576"/>
           <a:lstStyle/>
           <a:p>
-            <a:pPr algn="ctr">
-              <a:spcAft>
-                <a:spcPts val="0"/>
-              </a:spcAft>
-              <a:defRPr sz="2300" b="1">
-                <a:solidFill>
-                  <a:srgbClr val="122C4E"/>
-                </a:solidFill>
-                <a:latin typeface="Noto Sans CJK KR"/>
-              </a:defRPr>
-            </a:pPr>
-            <a:r>
-              <a:t>camera_link의 xyz를 0.30 0 0.26으로 바꾸어 발행하고 lidar_link와 위치 차이를 설명한다.</a:t>
-            </a:r>
-          </a:p>
-        </p:txBody>
-      </p:sp>
-      <p:sp>
-        <p:nvSpPr>
-          <p:cNvPr id="8" name="TextBox 7"/>
+            <a:pPr algn="l">
+              <a:spcAft>
+                <a:spcPts val="0"/>
+              </a:spcAft>
+              <a:defRPr sz="1600" b="0">
+                <a:solidFill>
+                  <a:srgbClr val="FFFFFF"/>
+                </a:solidFill>
+                <a:latin typeface="DejaVu Sans Mono"/>
+              </a:defRPr>
+            </a:pPr>
+            <a:r>
+              <a:t>ros2 topic echo /tf_static --once</a:t>
+            </a:r>
+            <a:br/>
+            <a:r>
+              <a:t>ros2 run tf2_tools view_frames</a:t>
+            </a:r>
+          </a:p>
+        </p:txBody>
+      </p:sp>
+      <p:sp>
+        <p:nvSpPr>
+          <p:cNvPr id="8" name="Rounded Rectangle 7"/>
+          <p:cNvSpPr/>
+          <p:nvPr/>
+        </p:nvSpPr>
+        <p:spPr>
+          <a:xfrm>
+            <a:off x="658368" y="4206240"/>
+            <a:ext cx="10972800" cy="1554480"/>
+          </a:xfrm>
+          <a:prstGeom prst="roundRect">
+            <a:avLst/>
+          </a:prstGeom>
+          <a:solidFill>
+            <a:srgbClr val="F4F7FB"/>
+          </a:solidFill>
+          <a:ln>
+            <a:solidFill>
+              <a:srgbClr val="D1DFD5"/>
+            </a:solidFill>
+          </a:ln>
+        </p:spPr>
+        <p:style>
+          <a:lnRef idx="1">
+            <a:schemeClr val="accent1"/>
+          </a:lnRef>
+          <a:fillRef idx="3">
+            <a:schemeClr val="accent1"/>
+          </a:fillRef>
+          <a:effectRef idx="2">
+            <a:schemeClr val="accent1"/>
+          </a:effectRef>
+          <a:fontRef idx="minor">
+            <a:schemeClr val="lt1"/>
+          </a:fontRef>
+        </p:style>
+        <p:txBody>
+          <a:bodyPr rtlCol="0" anchor="ctr" wrap="square" lIns="73152" rIns="73152" tIns="36576" bIns="36576"/>
+          <a:lstStyle/>
+          <a:p>
+            <a:pPr algn="l">
+              <a:spcAft>
+                <a:spcPts val="0"/>
+              </a:spcAft>
+              <a:defRPr sz="1800" b="1">
+                <a:solidFill>
+                  <a:srgbClr val="2A8B5A"/>
+                </a:solidFill>
+                <a:latin typeface="Noto Sans CJK KR"/>
+              </a:defRPr>
+            </a:pPr>
+            <a:r>
+              <a:t>완료 체크</a:t>
+            </a:r>
+            <a:br/>
+            <a:r>
+              <a:t>□ 명령이 오류 없이 실행된다.</a:t>
+            </a:r>
+            <a:br/>
+            <a:r>
+              <a:t>□ 기대한 파일·topic·frame·parameter 이름이 보인다.</a:t>
+            </a:r>
+            <a:br/>
+            <a:r>
+              <a:t>□ 값의 단위와 방향을 한 문장으로 설명할 수 있다.</a:t>
+            </a:r>
+          </a:p>
+        </p:txBody>
+      </p:sp>
+      <p:sp>
+        <p:nvSpPr>
+          <p:cNvPr id="9" name="TextBox 8"/>
           <p:cNvSpPr txBox="1"/>
           <p:nvPr/>
         </p:nvSpPr>
         <p:spPr>
           <a:xfrm>
-            <a:off x="877824" y="4590288"/>
-            <a:ext cx="10241280" cy="594360"/>
+            <a:off x="731520" y="5989320"/>
+            <a:ext cx="10789920" cy="237744"/>
           </a:xfrm>
           <a:prstGeom prst="rect">
             <a:avLst/>
@@ -7068,19 +7296,19 @@
           </a:bodyPr>
           <a:lstStyle/>
           <a:p>
-            <a:pPr algn="ctr">
-              <a:spcAft>
-                <a:spcPts val="0"/>
-              </a:spcAft>
-              <a:defRPr sz="1900" b="1">
-                <a:solidFill>
-                  <a:srgbClr val="DB7E22"/>
-                </a:solidFill>
-                <a:latin typeface="Noto Sans CJK KR"/>
-              </a:defRPr>
-            </a:pPr>
-            <a:r>
-              <a:t>기록할 것: 바꾼 값(단위) · 기대한 변화 · 실제 출력/화면 · 원래 값으로 되돌린 결과</a:t>
+            <a:pPr algn="l">
+              <a:spcAft>
+                <a:spcPts val="0"/>
+              </a:spcAft>
+              <a:defRPr sz="1500" b="1">
+                <a:solidFill>
+                  <a:srgbClr val="122C4E"/>
+                </a:solidFill>
+                <a:latin typeface="Noto Sans CJK KR"/>
+              </a:defRPr>
+            </a:pPr>
+            <a:r>
+              <a:t>완료 조건: 정적 TF를 발행하고 frame 이름과 RViz Fixed Frame의 관계를 설명한다.</a:t>
             </a:r>
           </a:p>
         </p:txBody>
@@ -7137,7 +7365,7 @@
               </a:defRPr>
             </a:pPr>
             <a:r>
-              <a:t>내 프로젝트 체크포인트를 저장하고 다음 모듈로 넘긴다</a:t>
+              <a:t>막히면: 증상 → 우선 확인 → 재검증</a:t>
             </a:r>
           </a:p>
         </p:txBody>
@@ -7176,7 +7404,7 @@
               </a:defRPr>
             </a:pPr>
             <a:r>
-              <a:t>Complete는 복구용 비교 기준이고, 다음 단계는 내가 직접 만든 workspace에서 계속합니다.</a:t>
+              <a:t>오류 메시지를 숨기지 않고 같은 순서로 점검합니다.</a:t>
             </a:r>
           </a:p>
         </p:txBody>
@@ -7312,7 +7540,7 @@
               </a:defRPr>
             </a:pPr>
             <a:r>
-              <a:t>현재 단계 체크포인트    |    현재 폴더 ~/ros2_curri/my_agv_ws    |    현재 터미널</a:t>
+              <a:t>현재 단계 오류 대응    |    현재 폴더 ~/ros2_curri/my_agv_ws    |    현재 터미널</a:t>
             </a:r>
           </a:p>
         </p:txBody>
@@ -7325,18 +7553,18 @@
         </p:nvSpPr>
         <p:spPr>
           <a:xfrm>
-            <a:off x="685800" y="1737360"/>
-            <a:ext cx="10972800" cy="3611880"/>
+            <a:off x="694944" y="1755648"/>
+            <a:ext cx="10972800" cy="1115568"/>
           </a:xfrm>
           <a:prstGeom prst="roundRect">
             <a:avLst/>
           </a:prstGeom>
           <a:solidFill>
-            <a:srgbClr val="F4F7FB"/>
+            <a:srgbClr val="FFF7F4"/>
           </a:solidFill>
           <a:ln>
             <a:solidFill>
-              <a:srgbClr val="D2DCE8"/>
+              <a:srgbClr val="EDBEB4"/>
             </a:solidFill>
           </a:ln>
         </p:spPr>
@@ -7370,111 +7598,8 @@
         </p:nvSpPr>
         <p:spPr>
           <a:xfrm>
-            <a:off x="896112" y="1993392"/>
-            <a:ext cx="10332720" cy="2971800"/>
-          </a:xfrm>
-          <a:prstGeom prst="rect">
-            <a:avLst/>
-          </a:prstGeom>
-          <a:noFill/>
-        </p:spPr>
-        <p:txBody>
-          <a:bodyPr wrap="square" lIns="109728" rIns="109728">
-            <a:spAutoFit/>
-          </a:bodyPr>
-          <a:lstStyle/>
-          <a:p>
-            <a:pPr>
-              <a:spcAft>
-                <a:spcPts val="800"/>
-              </a:spcAft>
-              <a:defRPr sz="1800">
-                <a:solidFill>
-                  <a:srgbClr val="122C4E"/>
-                </a:solidFill>
-                <a:latin typeface="Noto Sans CJK KR"/>
-              </a:defRPr>
-            </a:pPr>
-            <a:r>
-              <a:t>• □ 완료 화면: 정적 TF를 발행하고 frame 이름과 RViz Fixed Frame의 관계를 설명한다.</a:t>
-            </a:r>
-          </a:p>
-          <a:p>
-            <a:pPr>
-              <a:spcAft>
-                <a:spcPts val="800"/>
-              </a:spcAft>
-              <a:defRPr sz="1800">
-                <a:solidFill>
-                  <a:srgbClr val="122C4E"/>
-                </a:solidFill>
-                <a:latin typeface="Noto Sans CJK KR"/>
-              </a:defRPr>
-            </a:pPr>
-            <a:r>
-              <a:t>• □ 막혔을 때 비교할 Complete: blocks/A_ros2_basics/M04_tf2_frames/complete/</a:t>
-            </a:r>
-          </a:p>
-          <a:p>
-            <a:pPr>
-              <a:spcAft>
-                <a:spcPts val="800"/>
-              </a:spcAft>
-              <a:defRPr sz="1800">
-                <a:solidFill>
-                  <a:srgbClr val="122C4E"/>
-                </a:solidFill>
-                <a:latin typeface="Noto Sans CJK KR"/>
-              </a:defRPr>
-            </a:pPr>
-            <a:r>
-              <a:t>• □ 정상 로그·캡처: logs/validation.log, screenshots/validation_terminal.png</a:t>
-            </a:r>
-          </a:p>
-          <a:p>
-            <a:pPr>
-              <a:spcAft>
-                <a:spcPts val="800"/>
-              </a:spcAft>
-              <a:defRPr sz="1800">
-                <a:solidFill>
-                  <a:srgbClr val="122C4E"/>
-                </a:solidFill>
-                <a:latin typeface="Noto Sans CJK KR"/>
-              </a:defRPr>
-            </a:pPr>
-            <a:r>
-              <a:t>• □ 버전 식별: CHECKSUM_or_TAG.txt의 SHA-256 manifest</a:t>
-            </a:r>
-          </a:p>
-          <a:p>
-            <a:pPr>
-              <a:spcAft>
-                <a:spcPts val="800"/>
-              </a:spcAft>
-              <a:defRPr sz="1800">
-                <a:solidFill>
-                  <a:srgbClr val="122C4E"/>
-                </a:solidFill>
-                <a:latin typeface="Noto Sans CJK KR"/>
-              </a:defRPr>
-            </a:pPr>
-            <a:r>
-              <a:t>• □ 다음 시작 조건: M05 URDF link/joint</a:t>
-            </a:r>
-          </a:p>
-        </p:txBody>
-      </p:sp>
-      <p:sp>
-        <p:nvSpPr>
-          <p:cNvPr id="9" name="TextBox 8"/>
-          <p:cNvSpPr txBox="1"/>
-          <p:nvPr/>
-        </p:nvSpPr>
-        <p:spPr>
-          <a:xfrm>
-            <a:off x="868680" y="5596128"/>
-            <a:ext cx="10515600" cy="338328"/>
+            <a:off x="896112" y="1901952"/>
+            <a:ext cx="2926080" cy="274320"/>
           </a:xfrm>
           <a:prstGeom prst="rect">
             <a:avLst/>
@@ -7487,19 +7612,228 @@
           </a:bodyPr>
           <a:lstStyle/>
           <a:p>
+            <a:pPr algn="l">
+              <a:spcAft>
+                <a:spcPts val="0"/>
+              </a:spcAft>
+              <a:defRPr sz="1800" b="1">
+                <a:solidFill>
+                  <a:srgbClr val="BE3B3B"/>
+                </a:solidFill>
+                <a:latin typeface="Noto Sans CJK KR"/>
+              </a:defRPr>
+            </a:pPr>
+            <a:r>
+              <a:t>증상 1: RViz에 아무것도 안 보임</a:t>
+            </a:r>
+          </a:p>
+        </p:txBody>
+      </p:sp>
+      <p:sp>
+        <p:nvSpPr>
+          <p:cNvPr id="9" name="TextBox 8"/>
+          <p:cNvSpPr txBox="1"/>
+          <p:nvPr/>
+        </p:nvSpPr>
+        <p:spPr>
+          <a:xfrm>
+            <a:off x="3794760" y="1883664"/>
+            <a:ext cx="7543800" cy="621792"/>
+          </a:xfrm>
+          <a:prstGeom prst="rect">
+            <a:avLst/>
+          </a:prstGeom>
+          <a:noFill/>
+        </p:spPr>
+        <p:txBody>
+          <a:bodyPr wrap="square" lIns="73152" rIns="73152" tIns="36576" bIns="36576">
+            <a:spAutoFit/>
+          </a:bodyPr>
+          <a:lstStyle/>
+          <a:p>
+            <a:pPr algn="l">
+              <a:spcAft>
+                <a:spcPts val="0"/>
+              </a:spcAft>
+              <a:defRPr sz="1600" b="0">
+                <a:solidFill>
+                  <a:srgbClr val="122C4E"/>
+                </a:solidFill>
+                <a:latin typeface="Noto Sans CJK KR"/>
+              </a:defRPr>
+            </a:pPr>
+            <a:r>
+              <a:t>우선 확인: Fixed Frame과 TF 존재 여부를 먼저 확인한다.</a:t>
+            </a:r>
+            <a:br/>
+            <a:r>
+              <a:t>수정 후: ros2 topic echo /tf_static --once</a:t>
+            </a:r>
+          </a:p>
+        </p:txBody>
+      </p:sp>
+      <p:sp>
+        <p:nvSpPr>
+          <p:cNvPr id="10" name="Rounded Rectangle 9"/>
+          <p:cNvSpPr/>
+          <p:nvPr/>
+        </p:nvSpPr>
+        <p:spPr>
+          <a:xfrm>
+            <a:off x="694944" y="3172968"/>
+            <a:ext cx="10972800" cy="1115568"/>
+          </a:xfrm>
+          <a:prstGeom prst="roundRect">
+            <a:avLst/>
+          </a:prstGeom>
+          <a:solidFill>
+            <a:srgbClr val="FFF7F4"/>
+          </a:solidFill>
+          <a:ln>
+            <a:solidFill>
+              <a:srgbClr val="EDBEB4"/>
+            </a:solidFill>
+          </a:ln>
+        </p:spPr>
+        <p:style>
+          <a:lnRef idx="1">
+            <a:schemeClr val="accent1"/>
+          </a:lnRef>
+          <a:fillRef idx="3">
+            <a:schemeClr val="accent1"/>
+          </a:fillRef>
+          <a:effectRef idx="2">
+            <a:schemeClr val="accent1"/>
+          </a:effectRef>
+          <a:fontRef idx="minor">
+            <a:schemeClr val="lt1"/>
+          </a:fontRef>
+        </p:style>
+        <p:txBody>
+          <a:bodyPr rtlCol="0" anchor="ctr"/>
+          <a:lstStyle/>
+          <a:p>
+            <a:pPr algn="ctr"/>
+          </a:p>
+        </p:txBody>
+      </p:sp>
+      <p:sp>
+        <p:nvSpPr>
+          <p:cNvPr id="11" name="TextBox 10"/>
+          <p:cNvSpPr txBox="1"/>
+          <p:nvPr/>
+        </p:nvSpPr>
+        <p:spPr>
+          <a:xfrm>
+            <a:off x="896112" y="3319272"/>
+            <a:ext cx="2926080" cy="274320"/>
+          </a:xfrm>
+          <a:prstGeom prst="rect">
+            <a:avLst/>
+          </a:prstGeom>
+          <a:noFill/>
+        </p:spPr>
+        <p:txBody>
+          <a:bodyPr wrap="square" lIns="73152" rIns="73152" tIns="36576" bIns="36576">
+            <a:spAutoFit/>
+          </a:bodyPr>
+          <a:lstStyle/>
+          <a:p>
+            <a:pPr algn="l">
+              <a:spcAft>
+                <a:spcPts val="0"/>
+              </a:spcAft>
+              <a:defRPr sz="1800" b="1">
+                <a:solidFill>
+                  <a:srgbClr val="BE3B3B"/>
+                </a:solidFill>
+                <a:latin typeface="Noto Sans CJK KR"/>
+              </a:defRPr>
+            </a:pPr>
+            <a:r>
+              <a:t>증상 2: 센서가 엉뚱한 방향</a:t>
+            </a:r>
+          </a:p>
+        </p:txBody>
+      </p:sp>
+      <p:sp>
+        <p:nvSpPr>
+          <p:cNvPr id="12" name="TextBox 11"/>
+          <p:cNvSpPr txBox="1"/>
+          <p:nvPr/>
+        </p:nvSpPr>
+        <p:spPr>
+          <a:xfrm>
+            <a:off x="3794760" y="3300984"/>
+            <a:ext cx="7543800" cy="621792"/>
+          </a:xfrm>
+          <a:prstGeom prst="rect">
+            <a:avLst/>
+          </a:prstGeom>
+          <a:noFill/>
+        </p:spPr>
+        <p:txBody>
+          <a:bodyPr wrap="square" lIns="73152" rIns="73152" tIns="36576" bIns="36576">
+            <a:spAutoFit/>
+          </a:bodyPr>
+          <a:lstStyle/>
+          <a:p>
+            <a:pPr algn="l">
+              <a:spcAft>
+                <a:spcPts val="0"/>
+              </a:spcAft>
+              <a:defRPr sz="1600" b="0">
+                <a:solidFill>
+                  <a:srgbClr val="122C4E"/>
+                </a:solidFill>
+                <a:latin typeface="Noto Sans CJK KR"/>
+              </a:defRPr>
+            </a:pPr>
+            <a:r>
+              <a:t>우선 확인: rpy 단위·parent/child 순서·축 방향을 점검한다.</a:t>
+            </a:r>
+            <a:br/>
+            <a:r>
+              <a:t>수정 후: ros2 topic echo /tf_static --once</a:t>
+            </a:r>
+          </a:p>
+        </p:txBody>
+      </p:sp>
+      <p:sp>
+        <p:nvSpPr>
+          <p:cNvPr id="13" name="TextBox 12"/>
+          <p:cNvSpPr txBox="1"/>
+          <p:nvPr/>
+        </p:nvSpPr>
+        <p:spPr>
+          <a:xfrm>
+            <a:off x="822960" y="5102352"/>
+            <a:ext cx="10607040" cy="402336"/>
+          </a:xfrm>
+          <a:prstGeom prst="rect">
+            <a:avLst/>
+          </a:prstGeom>
+          <a:noFill/>
+        </p:spPr>
+        <p:txBody>
+          <a:bodyPr wrap="square" lIns="73152" rIns="73152" tIns="36576" bIns="36576">
+            <a:spAutoFit/>
+          </a:bodyPr>
+          <a:lstStyle/>
+          <a:p>
             <a:pPr algn="ctr">
               <a:spcAft>
                 <a:spcPts val="0"/>
               </a:spcAft>
-              <a:defRPr sz="1700" b="1">
-                <a:solidFill>
-                  <a:srgbClr val="2A8B5A"/>
-                </a:solidFill>
-                <a:latin typeface="Noto Sans CJK KR"/>
-              </a:defRPr>
-            </a:pPr>
-            <a:r>
-              <a:t>다음 모듈을 시작하기 전, 내 src의 변경사항을 저장하고 현재 완료 조건을 다시 확인합니다.</a:t>
+              <a:defRPr sz="1800" b="1">
+                <a:solidFill>
+                  <a:srgbClr val="DB7E22"/>
+                </a:solidFill>
+                <a:latin typeface="Noto Sans CJK KR"/>
+              </a:defRPr>
+            </a:pPr>
+            <a:r>
+              <a:t>공통 순서: ① 현재 폴더 ② source ③ 파일 경로 ④ 이름/타입/단위 ⑤ build·source 후 재실행</a:t>
             </a:r>
           </a:p>
         </p:txBody>
@@ -7556,6 +7890,754 @@
               </a:defRPr>
             </a:pPr>
             <a:r>
+              <a:t>미니 실습: 값 하나를 바꾸고 결과를 비교한다</a:t>
+            </a:r>
+          </a:p>
+        </p:txBody>
+      </p:sp>
+      <p:sp>
+        <p:nvSpPr>
+          <p:cNvPr id="3" name="TextBox 2"/>
+          <p:cNvSpPr txBox="1"/>
+          <p:nvPr/>
+        </p:nvSpPr>
+        <p:spPr>
+          <a:xfrm>
+            <a:off x="603504" y="859536"/>
+            <a:ext cx="10698480" cy="292608"/>
+          </a:xfrm>
+          <a:prstGeom prst="rect">
+            <a:avLst/>
+          </a:prstGeom>
+          <a:noFill/>
+        </p:spPr>
+        <p:txBody>
+          <a:bodyPr wrap="square" lIns="73152" rIns="73152" tIns="36576" bIns="36576">
+            <a:spAutoFit/>
+          </a:bodyPr>
+          <a:lstStyle/>
+          <a:p>
+            <a:pPr algn="l">
+              <a:spcAft>
+                <a:spcPts val="0"/>
+              </a:spcAft>
+              <a:defRPr sz="1700" b="0">
+                <a:solidFill>
+                  <a:srgbClr val="5C6672"/>
+                </a:solidFill>
+                <a:latin typeface="Noto Sans CJK KR"/>
+              </a:defRPr>
+            </a:pPr>
+            <a:r>
+              <a:t>정상 결과를 만든 뒤에는 한 번에 하나의 값만 바꿉니다.</a:t>
+            </a:r>
+          </a:p>
+        </p:txBody>
+      </p:sp>
+      <p:sp>
+        <p:nvSpPr>
+          <p:cNvPr id="4" name="TextBox 3"/>
+          <p:cNvSpPr txBox="1"/>
+          <p:nvPr/>
+        </p:nvSpPr>
+        <p:spPr>
+          <a:xfrm>
+            <a:off x="530352" y="6510528"/>
+            <a:ext cx="7772400" cy="201168"/>
+          </a:xfrm>
+          <a:prstGeom prst="rect">
+            <a:avLst/>
+          </a:prstGeom>
+          <a:noFill/>
+        </p:spPr>
+        <p:txBody>
+          <a:bodyPr wrap="square" lIns="73152" rIns="73152" tIns="36576" bIns="36576">
+            <a:spAutoFit/>
+          </a:bodyPr>
+          <a:lstStyle/>
+          <a:p>
+            <a:pPr algn="l">
+              <a:spcAft>
+                <a:spcPts val="0"/>
+              </a:spcAft>
+              <a:defRPr sz="1000" b="0">
+                <a:solidFill>
+                  <a:srgbClr val="5C6672"/>
+                </a:solidFill>
+                <a:latin typeface="Noto Sans CJK KR"/>
+              </a:defRPr>
+            </a:pPr>
+            <a:r>
+              <a:t>ROS 2 Jazzy · Gazebo Harmonic · M04 · 따라 하기형 AGV 실습</a:t>
+            </a:r>
+          </a:p>
+        </p:txBody>
+      </p:sp>
+      <p:sp>
+        <p:nvSpPr>
+          <p:cNvPr id="5" name="TextBox 4"/>
+          <p:cNvSpPr txBox="1"/>
+          <p:nvPr/>
+        </p:nvSpPr>
+        <p:spPr>
+          <a:xfrm>
+            <a:off x="9144000" y="6510528"/>
+            <a:ext cx="2468880" cy="201168"/>
+          </a:xfrm>
+          <a:prstGeom prst="rect">
+            <a:avLst/>
+          </a:prstGeom>
+          <a:noFill/>
+        </p:spPr>
+        <p:txBody>
+          <a:bodyPr wrap="square" lIns="73152" rIns="73152" tIns="36576" bIns="36576">
+            <a:spAutoFit/>
+          </a:bodyPr>
+          <a:lstStyle/>
+          <a:p>
+            <a:pPr algn="r">
+              <a:spcAft>
+                <a:spcPts val="0"/>
+              </a:spcAft>
+              <a:defRPr sz="1000" b="0">
+                <a:solidFill>
+                  <a:srgbClr val="5C6672"/>
+                </a:solidFill>
+                <a:latin typeface="Noto Sans CJK KR"/>
+              </a:defRPr>
+            </a:pPr>
+            <a:r>
+              <a:t>명령·파일 경로는 슬라이드에서 복사 가능</a:t>
+            </a:r>
+          </a:p>
+        </p:txBody>
+      </p:sp>
+      <p:sp>
+        <p:nvSpPr>
+          <p:cNvPr id="6" name="Rectangle 5"/>
+          <p:cNvSpPr/>
+          <p:nvPr/>
+        </p:nvSpPr>
+        <p:spPr>
+          <a:xfrm>
+            <a:off x="566928" y="1188720"/>
+            <a:ext cx="11064240" cy="347472"/>
+          </a:xfrm>
+          <a:prstGeom prst="rect">
+            <a:avLst/>
+          </a:prstGeom>
+          <a:solidFill>
+            <a:srgbClr val="F4F7FB"/>
+          </a:solidFill>
+          <a:ln>
+            <a:solidFill>
+              <a:srgbClr val="F4F7FB"/>
+            </a:solidFill>
+          </a:ln>
+        </p:spPr>
+        <p:style>
+          <a:lnRef idx="1">
+            <a:schemeClr val="accent1"/>
+          </a:lnRef>
+          <a:fillRef idx="3">
+            <a:schemeClr val="accent1"/>
+          </a:fillRef>
+          <a:effectRef idx="2">
+            <a:schemeClr val="accent1"/>
+          </a:effectRef>
+          <a:fontRef idx="minor">
+            <a:schemeClr val="lt1"/>
+          </a:fontRef>
+        </p:style>
+        <p:txBody>
+          <a:bodyPr rtlCol="0" anchor="ctr" wrap="square" lIns="73152" rIns="73152" tIns="36576" bIns="36576"/>
+          <a:lstStyle/>
+          <a:p>
+            <a:pPr algn="l">
+              <a:spcAft>
+                <a:spcPts val="0"/>
+              </a:spcAft>
+              <a:defRPr sz="1300" b="1">
+                <a:solidFill>
+                  <a:srgbClr val="122C4E"/>
+                </a:solidFill>
+                <a:latin typeface="Noto Sans CJK KR"/>
+              </a:defRPr>
+            </a:pPr>
+            <a:r>
+              <a:t>현재 단계 미니 실습    |    현재 폴더 ~/ros2_curri/my_agv_ws    |    현재 터미널</a:t>
+            </a:r>
+          </a:p>
+        </p:txBody>
+      </p:sp>
+      <p:sp>
+        <p:nvSpPr>
+          <p:cNvPr id="7" name="Rounded Rectangle 6"/>
+          <p:cNvSpPr/>
+          <p:nvPr/>
+        </p:nvSpPr>
+        <p:spPr>
+          <a:xfrm>
+            <a:off x="749808" y="1874519"/>
+            <a:ext cx="10652760" cy="1993392"/>
+          </a:xfrm>
+          <a:prstGeom prst="roundRect">
+            <a:avLst/>
+          </a:prstGeom>
+          <a:solidFill>
+            <a:srgbClr val="FFF8EB"/>
+          </a:solidFill>
+          <a:ln>
+            <a:solidFill>
+              <a:srgbClr val="ECC680"/>
+            </a:solidFill>
+          </a:ln>
+        </p:spPr>
+        <p:style>
+          <a:lnRef idx="1">
+            <a:schemeClr val="accent1"/>
+          </a:lnRef>
+          <a:fillRef idx="3">
+            <a:schemeClr val="accent1"/>
+          </a:fillRef>
+          <a:effectRef idx="2">
+            <a:schemeClr val="accent1"/>
+          </a:effectRef>
+          <a:fontRef idx="minor">
+            <a:schemeClr val="lt1"/>
+          </a:fontRef>
+        </p:style>
+        <p:txBody>
+          <a:bodyPr rtlCol="0" anchor="ctr" wrap="square" lIns="73152" rIns="73152" tIns="36576" bIns="36576"/>
+          <a:lstStyle/>
+          <a:p>
+            <a:pPr algn="ctr">
+              <a:spcAft>
+                <a:spcPts val="0"/>
+              </a:spcAft>
+              <a:defRPr sz="2300" b="1">
+                <a:solidFill>
+                  <a:srgbClr val="122C4E"/>
+                </a:solidFill>
+                <a:latin typeface="Noto Sans CJK KR"/>
+              </a:defRPr>
+            </a:pPr>
+            <a:r>
+              <a:t>camera_link의 xyz를 0.30 0 0.26으로 바꾸어 발행하고 lidar_link와 위치 차이를 설명한다.</a:t>
+            </a:r>
+          </a:p>
+        </p:txBody>
+      </p:sp>
+      <p:sp>
+        <p:nvSpPr>
+          <p:cNvPr id="8" name="TextBox 7"/>
+          <p:cNvSpPr txBox="1"/>
+          <p:nvPr/>
+        </p:nvSpPr>
+        <p:spPr>
+          <a:xfrm>
+            <a:off x="877824" y="4590288"/>
+            <a:ext cx="10241280" cy="594360"/>
+          </a:xfrm>
+          <a:prstGeom prst="rect">
+            <a:avLst/>
+          </a:prstGeom>
+          <a:noFill/>
+        </p:spPr>
+        <p:txBody>
+          <a:bodyPr wrap="square" lIns="73152" rIns="73152" tIns="36576" bIns="36576">
+            <a:spAutoFit/>
+          </a:bodyPr>
+          <a:lstStyle/>
+          <a:p>
+            <a:pPr algn="ctr">
+              <a:spcAft>
+                <a:spcPts val="0"/>
+              </a:spcAft>
+              <a:defRPr sz="1900" b="1">
+                <a:solidFill>
+                  <a:srgbClr val="DB7E22"/>
+                </a:solidFill>
+                <a:latin typeface="Noto Sans CJK KR"/>
+              </a:defRPr>
+            </a:pPr>
+            <a:r>
+              <a:t>기록할 것: 바꾼 값(단위) · 기대한 변화 · 실제 출력/화면 · 원래 값으로 되돌린 결과</a:t>
+            </a:r>
+          </a:p>
+        </p:txBody>
+      </p:sp>
+    </p:spTree>
+  </p:cSld>
+  <p:clrMapOvr>
+    <a:masterClrMapping/>
+  </p:clrMapOvr>
+</p:sld>
+</file>
+
+<file path=ppt/slides/slide17.xml><?xml version="1.0" encoding="utf-8"?>
+<p:sld xmlns:a="http://schemas.openxmlformats.org/drawingml/2006/main" xmlns:p="http://schemas.openxmlformats.org/presentationml/2006/main" xmlns:r="http://schemas.openxmlformats.org/officeDocument/2006/relationships">
+  <p:cSld>
+    <p:spTree>
+      <p:nvGrpSpPr>
+        <p:cNvPr id="1" name=""/>
+        <p:cNvGrpSpPr/>
+        <p:nvPr/>
+      </p:nvGrpSpPr>
+      <p:grpSpPr/>
+      <p:sp>
+        <p:nvSpPr>
+          <p:cNvPr id="2" name="TextBox 1"/>
+          <p:cNvSpPr txBox="1"/>
+          <p:nvPr/>
+        </p:nvSpPr>
+        <p:spPr>
+          <a:xfrm>
+            <a:off x="566928" y="347472"/>
+            <a:ext cx="10881360" cy="438912"/>
+          </a:xfrm>
+          <a:prstGeom prst="rect">
+            <a:avLst/>
+          </a:prstGeom>
+          <a:noFill/>
+        </p:spPr>
+        <p:txBody>
+          <a:bodyPr wrap="square" lIns="73152" rIns="73152" tIns="36576" bIns="36576">
+            <a:spAutoFit/>
+          </a:bodyPr>
+          <a:lstStyle/>
+          <a:p>
+            <a:pPr algn="l">
+              <a:spcAft>
+                <a:spcPts val="0"/>
+              </a:spcAft>
+              <a:defRPr sz="3200" b="1">
+                <a:solidFill>
+                  <a:srgbClr val="122C4E"/>
+                </a:solidFill>
+                <a:latin typeface="Noto Sans CJK KR"/>
+              </a:defRPr>
+            </a:pPr>
+            <a:r>
+              <a:t>내 프로젝트 체크포인트를 저장하고 다음 모듈로 넘긴다</a:t>
+            </a:r>
+          </a:p>
+        </p:txBody>
+      </p:sp>
+      <p:sp>
+        <p:nvSpPr>
+          <p:cNvPr id="3" name="TextBox 2"/>
+          <p:cNvSpPr txBox="1"/>
+          <p:nvPr/>
+        </p:nvSpPr>
+        <p:spPr>
+          <a:xfrm>
+            <a:off x="603504" y="859536"/>
+            <a:ext cx="10698480" cy="292608"/>
+          </a:xfrm>
+          <a:prstGeom prst="rect">
+            <a:avLst/>
+          </a:prstGeom>
+          <a:noFill/>
+        </p:spPr>
+        <p:txBody>
+          <a:bodyPr wrap="square" lIns="73152" rIns="73152" tIns="36576" bIns="36576">
+            <a:spAutoFit/>
+          </a:bodyPr>
+          <a:lstStyle/>
+          <a:p>
+            <a:pPr algn="l">
+              <a:spcAft>
+                <a:spcPts val="0"/>
+              </a:spcAft>
+              <a:defRPr sz="1700" b="0">
+                <a:solidFill>
+                  <a:srgbClr val="5C6672"/>
+                </a:solidFill>
+                <a:latin typeface="Noto Sans CJK KR"/>
+              </a:defRPr>
+            </a:pPr>
+            <a:r>
+              <a:t>Complete는 복구용 비교 기준이고, 다음 단계는 내가 직접 만든 workspace에서 계속합니다.</a:t>
+            </a:r>
+          </a:p>
+        </p:txBody>
+      </p:sp>
+      <p:sp>
+        <p:nvSpPr>
+          <p:cNvPr id="4" name="TextBox 3"/>
+          <p:cNvSpPr txBox="1"/>
+          <p:nvPr/>
+        </p:nvSpPr>
+        <p:spPr>
+          <a:xfrm>
+            <a:off x="530352" y="6510528"/>
+            <a:ext cx="7772400" cy="201168"/>
+          </a:xfrm>
+          <a:prstGeom prst="rect">
+            <a:avLst/>
+          </a:prstGeom>
+          <a:noFill/>
+        </p:spPr>
+        <p:txBody>
+          <a:bodyPr wrap="square" lIns="73152" rIns="73152" tIns="36576" bIns="36576">
+            <a:spAutoFit/>
+          </a:bodyPr>
+          <a:lstStyle/>
+          <a:p>
+            <a:pPr algn="l">
+              <a:spcAft>
+                <a:spcPts val="0"/>
+              </a:spcAft>
+              <a:defRPr sz="1000" b="0">
+                <a:solidFill>
+                  <a:srgbClr val="5C6672"/>
+                </a:solidFill>
+                <a:latin typeface="Noto Sans CJK KR"/>
+              </a:defRPr>
+            </a:pPr>
+            <a:r>
+              <a:t>ROS 2 Jazzy · Gazebo Harmonic · M04 · 따라 하기형 AGV 실습</a:t>
+            </a:r>
+          </a:p>
+        </p:txBody>
+      </p:sp>
+      <p:sp>
+        <p:nvSpPr>
+          <p:cNvPr id="5" name="TextBox 4"/>
+          <p:cNvSpPr txBox="1"/>
+          <p:nvPr/>
+        </p:nvSpPr>
+        <p:spPr>
+          <a:xfrm>
+            <a:off x="9144000" y="6510528"/>
+            <a:ext cx="2468880" cy="201168"/>
+          </a:xfrm>
+          <a:prstGeom prst="rect">
+            <a:avLst/>
+          </a:prstGeom>
+          <a:noFill/>
+        </p:spPr>
+        <p:txBody>
+          <a:bodyPr wrap="square" lIns="73152" rIns="73152" tIns="36576" bIns="36576">
+            <a:spAutoFit/>
+          </a:bodyPr>
+          <a:lstStyle/>
+          <a:p>
+            <a:pPr algn="r">
+              <a:spcAft>
+                <a:spcPts val="0"/>
+              </a:spcAft>
+              <a:defRPr sz="1000" b="0">
+                <a:solidFill>
+                  <a:srgbClr val="5C6672"/>
+                </a:solidFill>
+                <a:latin typeface="Noto Sans CJK KR"/>
+              </a:defRPr>
+            </a:pPr>
+            <a:r>
+              <a:t>명령·파일 경로는 슬라이드에서 복사 가능</a:t>
+            </a:r>
+          </a:p>
+        </p:txBody>
+      </p:sp>
+      <p:sp>
+        <p:nvSpPr>
+          <p:cNvPr id="6" name="Rectangle 5"/>
+          <p:cNvSpPr/>
+          <p:nvPr/>
+        </p:nvSpPr>
+        <p:spPr>
+          <a:xfrm>
+            <a:off x="566928" y="1188720"/>
+            <a:ext cx="11064240" cy="347472"/>
+          </a:xfrm>
+          <a:prstGeom prst="rect">
+            <a:avLst/>
+          </a:prstGeom>
+          <a:solidFill>
+            <a:srgbClr val="F4F7FB"/>
+          </a:solidFill>
+          <a:ln>
+            <a:solidFill>
+              <a:srgbClr val="F4F7FB"/>
+            </a:solidFill>
+          </a:ln>
+        </p:spPr>
+        <p:style>
+          <a:lnRef idx="1">
+            <a:schemeClr val="accent1"/>
+          </a:lnRef>
+          <a:fillRef idx="3">
+            <a:schemeClr val="accent1"/>
+          </a:fillRef>
+          <a:effectRef idx="2">
+            <a:schemeClr val="accent1"/>
+          </a:effectRef>
+          <a:fontRef idx="minor">
+            <a:schemeClr val="lt1"/>
+          </a:fontRef>
+        </p:style>
+        <p:txBody>
+          <a:bodyPr rtlCol="0" anchor="ctr" wrap="square" lIns="73152" rIns="73152" tIns="36576" bIns="36576"/>
+          <a:lstStyle/>
+          <a:p>
+            <a:pPr algn="l">
+              <a:spcAft>
+                <a:spcPts val="0"/>
+              </a:spcAft>
+              <a:defRPr sz="1300" b="1">
+                <a:solidFill>
+                  <a:srgbClr val="122C4E"/>
+                </a:solidFill>
+                <a:latin typeface="Noto Sans CJK KR"/>
+              </a:defRPr>
+            </a:pPr>
+            <a:r>
+              <a:t>현재 단계 체크포인트    |    현재 폴더 ~/ros2_curri/my_agv_ws    |    현재 터미널</a:t>
+            </a:r>
+          </a:p>
+        </p:txBody>
+      </p:sp>
+      <p:sp>
+        <p:nvSpPr>
+          <p:cNvPr id="7" name="Rounded Rectangle 6"/>
+          <p:cNvSpPr/>
+          <p:nvPr/>
+        </p:nvSpPr>
+        <p:spPr>
+          <a:xfrm>
+            <a:off x="685800" y="1737360"/>
+            <a:ext cx="10972800" cy="3611880"/>
+          </a:xfrm>
+          <a:prstGeom prst="roundRect">
+            <a:avLst/>
+          </a:prstGeom>
+          <a:solidFill>
+            <a:srgbClr val="F4F7FB"/>
+          </a:solidFill>
+          <a:ln>
+            <a:solidFill>
+              <a:srgbClr val="D2DCE8"/>
+            </a:solidFill>
+          </a:ln>
+        </p:spPr>
+        <p:style>
+          <a:lnRef idx="1">
+            <a:schemeClr val="accent1"/>
+          </a:lnRef>
+          <a:fillRef idx="3">
+            <a:schemeClr val="accent1"/>
+          </a:fillRef>
+          <a:effectRef idx="2">
+            <a:schemeClr val="accent1"/>
+          </a:effectRef>
+          <a:fontRef idx="minor">
+            <a:schemeClr val="lt1"/>
+          </a:fontRef>
+        </p:style>
+        <p:txBody>
+          <a:bodyPr rtlCol="0" anchor="ctr"/>
+          <a:lstStyle/>
+          <a:p>
+            <a:pPr algn="ctr"/>
+          </a:p>
+        </p:txBody>
+      </p:sp>
+      <p:sp>
+        <p:nvSpPr>
+          <p:cNvPr id="8" name="TextBox 7"/>
+          <p:cNvSpPr txBox="1"/>
+          <p:nvPr/>
+        </p:nvSpPr>
+        <p:spPr>
+          <a:xfrm>
+            <a:off x="896112" y="1993392"/>
+            <a:ext cx="10332720" cy="2971800"/>
+          </a:xfrm>
+          <a:prstGeom prst="rect">
+            <a:avLst/>
+          </a:prstGeom>
+          <a:noFill/>
+        </p:spPr>
+        <p:txBody>
+          <a:bodyPr wrap="square" lIns="109728" rIns="109728">
+            <a:spAutoFit/>
+          </a:bodyPr>
+          <a:lstStyle/>
+          <a:p>
+            <a:pPr>
+              <a:spcAft>
+                <a:spcPts val="800"/>
+              </a:spcAft>
+              <a:defRPr sz="1800">
+                <a:solidFill>
+                  <a:srgbClr val="122C4E"/>
+                </a:solidFill>
+                <a:latin typeface="Noto Sans CJK KR"/>
+              </a:defRPr>
+            </a:pPr>
+            <a:r>
+              <a:t>• □ 완료 화면: 정적 TF를 발행하고 frame 이름과 RViz Fixed Frame의 관계를 설명한다.</a:t>
+            </a:r>
+          </a:p>
+          <a:p>
+            <a:pPr>
+              <a:spcAft>
+                <a:spcPts val="800"/>
+              </a:spcAft>
+              <a:defRPr sz="1800">
+                <a:solidFill>
+                  <a:srgbClr val="122C4E"/>
+                </a:solidFill>
+                <a:latin typeface="Noto Sans CJK KR"/>
+              </a:defRPr>
+            </a:pPr>
+            <a:r>
+              <a:t>• □ 막혔을 때 비교할 Complete: blocks/A_ros2_basics/M04_tf2_frames/complete/</a:t>
+            </a:r>
+          </a:p>
+          <a:p>
+            <a:pPr>
+              <a:spcAft>
+                <a:spcPts val="800"/>
+              </a:spcAft>
+              <a:defRPr sz="1800">
+                <a:solidFill>
+                  <a:srgbClr val="122C4E"/>
+                </a:solidFill>
+                <a:latin typeface="Noto Sans CJK KR"/>
+              </a:defRPr>
+            </a:pPr>
+            <a:r>
+              <a:t>• □ 정상 로그·캡처: logs/validation.log, screenshots/validation_terminal.png</a:t>
+            </a:r>
+          </a:p>
+          <a:p>
+            <a:pPr>
+              <a:spcAft>
+                <a:spcPts val="800"/>
+              </a:spcAft>
+              <a:defRPr sz="1800">
+                <a:solidFill>
+                  <a:srgbClr val="122C4E"/>
+                </a:solidFill>
+                <a:latin typeface="Noto Sans CJK KR"/>
+              </a:defRPr>
+            </a:pPr>
+            <a:r>
+              <a:t>• □ 버전 식별: CHECKSUM_or_TAG.txt의 SHA-256 manifest</a:t>
+            </a:r>
+          </a:p>
+          <a:p>
+            <a:pPr>
+              <a:spcAft>
+                <a:spcPts val="800"/>
+              </a:spcAft>
+              <a:defRPr sz="1800">
+                <a:solidFill>
+                  <a:srgbClr val="122C4E"/>
+                </a:solidFill>
+                <a:latin typeface="Noto Sans CJK KR"/>
+              </a:defRPr>
+            </a:pPr>
+            <a:r>
+              <a:t>• □ 다음 시작 조건: M05 URDF link/joint</a:t>
+            </a:r>
+          </a:p>
+        </p:txBody>
+      </p:sp>
+      <p:sp>
+        <p:nvSpPr>
+          <p:cNvPr id="9" name="TextBox 8"/>
+          <p:cNvSpPr txBox="1"/>
+          <p:nvPr/>
+        </p:nvSpPr>
+        <p:spPr>
+          <a:xfrm>
+            <a:off x="868680" y="5596128"/>
+            <a:ext cx="10515600" cy="338328"/>
+          </a:xfrm>
+          <a:prstGeom prst="rect">
+            <a:avLst/>
+          </a:prstGeom>
+          <a:noFill/>
+        </p:spPr>
+        <p:txBody>
+          <a:bodyPr wrap="square" lIns="73152" rIns="73152" tIns="36576" bIns="36576">
+            <a:spAutoFit/>
+          </a:bodyPr>
+          <a:lstStyle/>
+          <a:p>
+            <a:pPr algn="ctr">
+              <a:spcAft>
+                <a:spcPts val="0"/>
+              </a:spcAft>
+              <a:defRPr sz="1700" b="1">
+                <a:solidFill>
+                  <a:srgbClr val="2A8B5A"/>
+                </a:solidFill>
+                <a:latin typeface="Noto Sans CJK KR"/>
+              </a:defRPr>
+            </a:pPr>
+            <a:r>
+              <a:t>다음 모듈을 시작하기 전, 내 src의 변경사항을 저장하고 현재 완료 조건을 다시 확인합니다.</a:t>
+            </a:r>
+          </a:p>
+        </p:txBody>
+      </p:sp>
+    </p:spTree>
+  </p:cSld>
+  <p:clrMapOvr>
+    <a:masterClrMapping/>
+  </p:clrMapOvr>
+</p:sld>
+</file>
+
+<file path=ppt/slides/slide18.xml><?xml version="1.0" encoding="utf-8"?>
+<p:sld xmlns:a="http://schemas.openxmlformats.org/drawingml/2006/main" xmlns:p="http://schemas.openxmlformats.org/presentationml/2006/main" xmlns:r="http://schemas.openxmlformats.org/officeDocument/2006/relationships">
+  <p:cSld>
+    <p:spTree>
+      <p:nvGrpSpPr>
+        <p:cNvPr id="1" name=""/>
+        <p:cNvGrpSpPr/>
+        <p:nvPr/>
+      </p:nvGrpSpPr>
+      <p:grpSpPr/>
+      <p:sp>
+        <p:nvSpPr>
+          <p:cNvPr id="2" name="TextBox 1"/>
+          <p:cNvSpPr txBox="1"/>
+          <p:nvPr/>
+        </p:nvSpPr>
+        <p:spPr>
+          <a:xfrm>
+            <a:off x="566928" y="347472"/>
+            <a:ext cx="10881360" cy="438912"/>
+          </a:xfrm>
+          <a:prstGeom prst="rect">
+            <a:avLst/>
+          </a:prstGeom>
+          <a:noFill/>
+        </p:spPr>
+        <p:txBody>
+          <a:bodyPr wrap="square" lIns="73152" rIns="73152" tIns="36576" bIns="36576">
+            <a:spAutoFit/>
+          </a:bodyPr>
+          <a:lstStyle/>
+          <a:p>
+            <a:pPr algn="l">
+              <a:spcAft>
+                <a:spcPts val="0"/>
+              </a:spcAft>
+              <a:defRPr sz="3200" b="1">
+                <a:solidFill>
+                  <a:srgbClr val="122C4E"/>
+                </a:solidFill>
+                <a:latin typeface="Noto Sans CJK KR"/>
+              </a:defRPr>
+            </a:pPr>
+            <a:r>
               <a:t>공식 참고 자료</a:t>
             </a:r>
           </a:p>
@@ -10765,7 +11847,7 @@
               </a:defRPr>
             </a:pPr>
             <a:r>
-              <a:t>구현 뒤 실행 1/2: 정적 TF를 발행한다</a:t>
+              <a:t>명령어를 코드처럼 읽기 (1/2)</a:t>
             </a:r>
           </a:p>
         </p:txBody>
@@ -10804,7 +11886,7 @@
               </a:defRPr>
             </a:pPr>
             <a:r>
-              <a:t>방금 직접 만든 파일을 실행·검사하며 다음 파일로 넘어갈 기준을 만듭니다.</a:t>
+              <a:t>새 파일을 만들지 않는 모듈도 한 줄씩 뜻과 화면에서 확인할 결과를 먼저 읽습니다.</a:t>
             </a:r>
           </a:p>
         </p:txBody>
@@ -10940,7 +12022,7 @@
               </a:defRPr>
             </a:pPr>
             <a:r>
-              <a:t>현재 단계 실행 1/2    |    현재 폴더 ~/ros2_curri/my_agv_ws    |    현재 터미널</a:t>
+              <a:t>현재 단계 명령 해설    |    현재 폴더 ~/ros2_curri/my_agv_ws    |    현재 터미널</a:t>
             </a:r>
           </a:p>
         </p:txBody>
@@ -10953,8 +12035,8 @@
         </p:nvSpPr>
         <p:spPr>
           <a:xfrm>
-            <a:off x="676656" y="1764792"/>
-            <a:ext cx="1828800" cy="347472"/>
+            <a:off x="694944" y="1664208"/>
+            <a:ext cx="10789920" cy="274320"/>
           </a:xfrm>
           <a:prstGeom prst="rect">
             <a:avLst/>
@@ -10967,72 +12049,33 @@
           </a:bodyPr>
           <a:lstStyle/>
           <a:p>
-            <a:pPr algn="l">
-              <a:spcAft>
-                <a:spcPts val="0"/>
-              </a:spcAft>
-              <a:defRPr sz="1800" b="1">
-                <a:solidFill>
-                  <a:srgbClr val="225B9B"/>
-                </a:solidFill>
-                <a:latin typeface="Noto Sans CJK KR"/>
-              </a:defRPr>
-            </a:pPr>
-            <a:r>
-              <a:t>왜 하는가</a:t>
-            </a:r>
-          </a:p>
-        </p:txBody>
-      </p:sp>
-      <p:sp>
-        <p:nvSpPr>
-          <p:cNvPr id="8" name="TextBox 7"/>
-          <p:cNvSpPr txBox="1"/>
-          <p:nvPr/>
-        </p:nvSpPr>
-        <p:spPr>
-          <a:xfrm>
-            <a:off x="676656" y="2103120"/>
-            <a:ext cx="10789920" cy="512064"/>
-          </a:xfrm>
-          <a:prstGeom prst="rect">
-            <a:avLst/>
-          </a:prstGeom>
-          <a:noFill/>
-        </p:spPr>
-        <p:txBody>
-          <a:bodyPr wrap="square" lIns="73152" rIns="73152" tIns="36576" bIns="36576">
-            <a:spAutoFit/>
-          </a:bodyPr>
-          <a:lstStyle/>
-          <a:p>
-            <a:pPr algn="l">
-              <a:spcAft>
-                <a:spcPts val="0"/>
-              </a:spcAft>
-              <a:defRPr sz="2000" b="0">
-                <a:solidFill>
-                  <a:srgbClr val="122C4E"/>
-                </a:solidFill>
-                <a:latin typeface="Noto Sans CJK KR"/>
-              </a:defRPr>
-            </a:pPr>
-            <a:r>
-              <a:t>고정 장착 센서는 시간에 따라 바뀌지 않는 transform을 사용한다.</a:t>
-            </a:r>
-          </a:p>
-        </p:txBody>
-      </p:sp>
-      <p:sp>
-        <p:nvSpPr>
-          <p:cNvPr id="9" name="Rounded Rectangle 8"/>
+            <a:pPr algn="ctr">
+              <a:spcAft>
+                <a:spcPts val="0"/>
+              </a:spcAft>
+              <a:defRPr sz="1500" b="1">
+                <a:solidFill>
+                  <a:srgbClr val="DB7E22"/>
+                </a:solidFill>
+                <a:latin typeface="Noto Sans CJK KR"/>
+              </a:defRPr>
+            </a:pPr>
+            <a:r>
+              <a:t>말로 먼저 답해 보세요: 이 명령은 무엇을 시작하고, 성공하면 어디에 무엇이 보일까요?</a:t>
+            </a:r>
+          </a:p>
+        </p:txBody>
+      </p:sp>
+      <p:sp>
+        <p:nvSpPr>
+          <p:cNvPr id="8" name="Rounded Rectangle 7"/>
           <p:cNvSpPr/>
           <p:nvPr/>
         </p:nvSpPr>
         <p:spPr>
           <a:xfrm>
-            <a:off x="676656" y="2871216"/>
-            <a:ext cx="10835640" cy="2331720"/>
+            <a:off x="658368" y="2359152"/>
+            <a:ext cx="4160520" cy="1417320"/>
           </a:xfrm>
           <a:prstGeom prst="roundRect">
             <a:avLst/>
@@ -11068,7 +12111,7 @@
               <a:spcAft>
                 <a:spcPts val="0"/>
               </a:spcAft>
-              <a:defRPr sz="1600" b="0">
+              <a:defRPr sz="1300" b="0">
                 <a:solidFill>
                   <a:srgbClr val="FFFFFF"/>
                 </a:solidFill>
@@ -11078,10 +12121,51 @@
             <a:r>
               <a:t>source /opt/ros/jazzy/setup.bash</a:t>
             </a:r>
-            <a:br/>
-            <a:r>
-              <a:t>ros2 run tf2_ros static_transform_publisher 0.12 0 0.28 0 0 0 base_link lidar_link</a:t>
-            </a:r>
+          </a:p>
+        </p:txBody>
+      </p:sp>
+      <p:sp>
+        <p:nvSpPr>
+          <p:cNvPr id="9" name="Rounded Rectangle 8"/>
+          <p:cNvSpPr/>
+          <p:nvPr/>
+        </p:nvSpPr>
+        <p:spPr>
+          <a:xfrm>
+            <a:off x="5029200" y="2359152"/>
+            <a:ext cx="6537960" cy="1417320"/>
+          </a:xfrm>
+          <a:prstGeom prst="roundRect">
+            <a:avLst/>
+          </a:prstGeom>
+          <a:solidFill>
+            <a:srgbClr val="F4F7FB"/>
+          </a:solidFill>
+          <a:ln>
+            <a:solidFill>
+              <a:srgbClr val="225B9B"/>
+            </a:solidFill>
+          </a:ln>
+        </p:spPr>
+        <p:style>
+          <a:lnRef idx="1">
+            <a:schemeClr val="accent1"/>
+          </a:lnRef>
+          <a:fillRef idx="3">
+            <a:schemeClr val="accent1"/>
+          </a:fillRef>
+          <a:effectRef idx="2">
+            <a:schemeClr val="accent1"/>
+          </a:effectRef>
+          <a:fontRef idx="minor">
+            <a:schemeClr val="lt1"/>
+          </a:fontRef>
+        </p:style>
+        <p:txBody>
+          <a:bodyPr rtlCol="0" anchor="ctr"/>
+          <a:lstStyle/>
+          <a:p>
+            <a:pPr algn="ctr"/>
           </a:p>
         </p:txBody>
       </p:sp>
@@ -11093,8 +12177,8 @@
         </p:nvSpPr>
         <p:spPr>
           <a:xfrm>
-            <a:off x="768096" y="5468112"/>
-            <a:ext cx="1143000" cy="256032"/>
+            <a:off x="5239512" y="2468880"/>
+            <a:ext cx="594360" cy="219456"/>
           </a:xfrm>
           <a:prstGeom prst="rect">
             <a:avLst/>
@@ -11111,15 +12195,15 @@
               <a:spcAft>
                 <a:spcPts val="0"/>
               </a:spcAft>
-              <a:defRPr sz="1800" b="1">
-                <a:solidFill>
-                  <a:srgbClr val="2A8B5A"/>
-                </a:solidFill>
-                <a:latin typeface="Noto Sans CJK KR"/>
-              </a:defRPr>
-            </a:pPr>
-            <a:r>
-              <a:t>확인</a:t>
+              <a:defRPr sz="1400" b="1">
+                <a:solidFill>
+                  <a:srgbClr val="225B9B"/>
+                </a:solidFill>
+                <a:latin typeface="Noto Sans CJK KR"/>
+              </a:defRPr>
+            </a:pPr>
+            <a:r>
+              <a:t>1.</a:t>
             </a:r>
           </a:p>
         </p:txBody>
@@ -11132,8 +12216,8 @@
         </p:nvSpPr>
         <p:spPr>
           <a:xfrm>
-            <a:off x="768096" y="5742432"/>
-            <a:ext cx="10561320" cy="347472"/>
+            <a:off x="5596128" y="2450592"/>
+            <a:ext cx="5696712" cy="493776"/>
           </a:xfrm>
           <a:prstGeom prst="rect">
             <a:avLst/>
@@ -11150,7 +12234,7 @@
               <a:spcAft>
                 <a:spcPts val="0"/>
               </a:spcAft>
-              <a:defRPr sz="1800" b="0">
+              <a:defRPr sz="1300" b="0">
                 <a:solidFill>
                   <a:srgbClr val="122C4E"/>
                 </a:solidFill>
@@ -11158,7 +12242,309 @@
               </a:defRPr>
             </a:pPr>
             <a:r>
-              <a:t>출력에서 topic·frame·파일 이름 또는 성공 메시지를 찾고, 맞지 않으면 다음 파일로 가지 않습니다.</a:t>
+              <a:t>뜻: 현재 terminal에 ROS 2 명령과 기본 package 경로를 등록합니다.</a:t>
+            </a:r>
+          </a:p>
+        </p:txBody>
+      </p:sp>
+      <p:sp>
+        <p:nvSpPr>
+          <p:cNvPr id="12" name="TextBox 11"/>
+          <p:cNvSpPr txBox="1"/>
+          <p:nvPr/>
+        </p:nvSpPr>
+        <p:spPr>
+          <a:xfrm>
+            <a:off x="5596128" y="3108960"/>
+            <a:ext cx="5696712" cy="457200"/>
+          </a:xfrm>
+          <a:prstGeom prst="rect">
+            <a:avLst/>
+          </a:prstGeom>
+          <a:noFill/>
+        </p:spPr>
+        <p:txBody>
+          <a:bodyPr wrap="square" lIns="73152" rIns="73152" tIns="36576" bIns="36576">
+            <a:spAutoFit/>
+          </a:bodyPr>
+          <a:lstStyle/>
+          <a:p>
+            <a:pPr algn="l">
+              <a:spcAft>
+                <a:spcPts val="0"/>
+              </a:spcAft>
+              <a:defRPr sz="1200" b="0">
+                <a:solidFill>
+                  <a:srgbClr val="2A8B5A"/>
+                </a:solidFill>
+                <a:latin typeface="Noto Sans CJK KR"/>
+              </a:defRPr>
+            </a:pPr>
+            <a:r>
+              <a:t>실행에서: 이 줄 뒤에 `ros2 --help`와 `ros2 run` 명령이 동작합니다.</a:t>
+            </a:r>
+          </a:p>
+        </p:txBody>
+      </p:sp>
+      <p:sp>
+        <p:nvSpPr>
+          <p:cNvPr id="13" name="Rounded Rectangle 12"/>
+          <p:cNvSpPr/>
+          <p:nvPr/>
+        </p:nvSpPr>
+        <p:spPr>
+          <a:xfrm>
+            <a:off x="658368" y="4078224"/>
+            <a:ext cx="4160520" cy="1417320"/>
+          </a:xfrm>
+          <a:prstGeom prst="roundRect">
+            <a:avLst/>
+          </a:prstGeom>
+          <a:solidFill>
+            <a:srgbClr val="1D232D"/>
+          </a:solidFill>
+          <a:ln>
+            <a:solidFill>
+              <a:srgbClr val="1D232D"/>
+            </a:solidFill>
+          </a:ln>
+        </p:spPr>
+        <p:style>
+          <a:lnRef idx="1">
+            <a:schemeClr val="accent1"/>
+          </a:lnRef>
+          <a:fillRef idx="3">
+            <a:schemeClr val="accent1"/>
+          </a:fillRef>
+          <a:effectRef idx="2">
+            <a:schemeClr val="accent1"/>
+          </a:effectRef>
+          <a:fontRef idx="minor">
+            <a:schemeClr val="lt1"/>
+          </a:fontRef>
+        </p:style>
+        <p:txBody>
+          <a:bodyPr rtlCol="0" anchor="ctr" wrap="square" lIns="73152" rIns="73152" tIns="36576" bIns="36576"/>
+          <a:lstStyle/>
+          <a:p>
+            <a:pPr algn="l">
+              <a:spcAft>
+                <a:spcPts val="0"/>
+              </a:spcAft>
+              <a:defRPr sz="1300" b="0">
+                <a:solidFill>
+                  <a:srgbClr val="FFFFFF"/>
+                </a:solidFill>
+                <a:latin typeface="DejaVu Sans Mono"/>
+              </a:defRPr>
+            </a:pPr>
+            <a:r>
+              <a:t>ros2 run tf2_ros static_transform_publisher 0.12 0 0.28 0</a:t>
+            </a:r>
+            <a:br/>
+            <a:r>
+              <a:t>0 0 base_link lidar_link</a:t>
+            </a:r>
+          </a:p>
+        </p:txBody>
+      </p:sp>
+      <p:sp>
+        <p:nvSpPr>
+          <p:cNvPr id="14" name="Rounded Rectangle 13"/>
+          <p:cNvSpPr/>
+          <p:nvPr/>
+        </p:nvSpPr>
+        <p:spPr>
+          <a:xfrm>
+            <a:off x="5029200" y="4078224"/>
+            <a:ext cx="6537960" cy="1417320"/>
+          </a:xfrm>
+          <a:prstGeom prst="roundRect">
+            <a:avLst/>
+          </a:prstGeom>
+          <a:solidFill>
+            <a:srgbClr val="F4F7FB"/>
+          </a:solidFill>
+          <a:ln>
+            <a:solidFill>
+              <a:srgbClr val="225B9B"/>
+            </a:solidFill>
+          </a:ln>
+        </p:spPr>
+        <p:style>
+          <a:lnRef idx="1">
+            <a:schemeClr val="accent1"/>
+          </a:lnRef>
+          <a:fillRef idx="3">
+            <a:schemeClr val="accent1"/>
+          </a:fillRef>
+          <a:effectRef idx="2">
+            <a:schemeClr val="accent1"/>
+          </a:effectRef>
+          <a:fontRef idx="minor">
+            <a:schemeClr val="lt1"/>
+          </a:fontRef>
+        </p:style>
+        <p:txBody>
+          <a:bodyPr rtlCol="0" anchor="ctr"/>
+          <a:lstStyle/>
+          <a:p>
+            <a:pPr algn="ctr"/>
+          </a:p>
+        </p:txBody>
+      </p:sp>
+      <p:sp>
+        <p:nvSpPr>
+          <p:cNvPr id="15" name="TextBox 14"/>
+          <p:cNvSpPr txBox="1"/>
+          <p:nvPr/>
+        </p:nvSpPr>
+        <p:spPr>
+          <a:xfrm>
+            <a:off x="5239512" y="4187952"/>
+            <a:ext cx="594360" cy="219456"/>
+          </a:xfrm>
+          <a:prstGeom prst="rect">
+            <a:avLst/>
+          </a:prstGeom>
+          <a:noFill/>
+        </p:spPr>
+        <p:txBody>
+          <a:bodyPr wrap="square" lIns="73152" rIns="73152" tIns="36576" bIns="36576">
+            <a:spAutoFit/>
+          </a:bodyPr>
+          <a:lstStyle/>
+          <a:p>
+            <a:pPr algn="l">
+              <a:spcAft>
+                <a:spcPts val="0"/>
+              </a:spcAft>
+              <a:defRPr sz="1400" b="1">
+                <a:solidFill>
+                  <a:srgbClr val="225B9B"/>
+                </a:solidFill>
+                <a:latin typeface="Noto Sans CJK KR"/>
+              </a:defRPr>
+            </a:pPr>
+            <a:r>
+              <a:t>2.</a:t>
+            </a:r>
+          </a:p>
+        </p:txBody>
+      </p:sp>
+      <p:sp>
+        <p:nvSpPr>
+          <p:cNvPr id="16" name="TextBox 15"/>
+          <p:cNvSpPr txBox="1"/>
+          <p:nvPr/>
+        </p:nvSpPr>
+        <p:spPr>
+          <a:xfrm>
+            <a:off x="5596128" y="4169663"/>
+            <a:ext cx="5696712" cy="493776"/>
+          </a:xfrm>
+          <a:prstGeom prst="rect">
+            <a:avLst/>
+          </a:prstGeom>
+          <a:noFill/>
+        </p:spPr>
+        <p:txBody>
+          <a:bodyPr wrap="square" lIns="73152" rIns="73152" tIns="36576" bIns="36576">
+            <a:spAutoFit/>
+          </a:bodyPr>
+          <a:lstStyle/>
+          <a:p>
+            <a:pPr algn="l">
+              <a:spcAft>
+                <a:spcPts val="0"/>
+              </a:spcAft>
+              <a:defRPr sz="1300" b="0">
+                <a:solidFill>
+                  <a:srgbClr val="122C4E"/>
+                </a:solidFill>
+                <a:latin typeface="Noto Sans CJK KR"/>
+              </a:defRPr>
+            </a:pPr>
+            <a:r>
+              <a:t>뜻: 숫자 xyz·rpy와 parent/child frame을 받아 움직이지 않는 TF를 발행합니다.</a:t>
+            </a:r>
+          </a:p>
+        </p:txBody>
+      </p:sp>
+      <p:sp>
+        <p:nvSpPr>
+          <p:cNvPr id="17" name="TextBox 16"/>
+          <p:cNvSpPr txBox="1"/>
+          <p:nvPr/>
+        </p:nvSpPr>
+        <p:spPr>
+          <a:xfrm>
+            <a:off x="5596128" y="4828032"/>
+            <a:ext cx="5696712" cy="457200"/>
+          </a:xfrm>
+          <a:prstGeom prst="rect">
+            <a:avLst/>
+          </a:prstGeom>
+          <a:noFill/>
+        </p:spPr>
+        <p:txBody>
+          <a:bodyPr wrap="square" lIns="73152" rIns="73152" tIns="36576" bIns="36576">
+            <a:spAutoFit/>
+          </a:bodyPr>
+          <a:lstStyle/>
+          <a:p>
+            <a:pPr algn="l">
+              <a:spcAft>
+                <a:spcPts val="0"/>
+              </a:spcAft>
+              <a:defRPr sz="1200" b="0">
+                <a:solidFill>
+                  <a:srgbClr val="2A8B5A"/>
+                </a:solidFill>
+                <a:latin typeface="Noto Sans CJK KR"/>
+              </a:defRPr>
+            </a:pPr>
+            <a:r>
+              <a:t>실행에서: `/tf_static`과 TF frame tree에서 base_link → lidar_link를 확인합니다.</a:t>
+            </a:r>
+          </a:p>
+        </p:txBody>
+      </p:sp>
+      <p:sp>
+        <p:nvSpPr>
+          <p:cNvPr id="18" name="TextBox 17"/>
+          <p:cNvSpPr txBox="1"/>
+          <p:nvPr/>
+        </p:nvSpPr>
+        <p:spPr>
+          <a:xfrm>
+            <a:off x="749808" y="6199632"/>
+            <a:ext cx="10698480" cy="182880"/>
+          </a:xfrm>
+          <a:prstGeom prst="rect">
+            <a:avLst/>
+          </a:prstGeom>
+          <a:noFill/>
+        </p:spPr>
+        <p:txBody>
+          <a:bodyPr wrap="square" lIns="73152" rIns="73152" tIns="36576" bIns="36576">
+            <a:spAutoFit/>
+          </a:bodyPr>
+          <a:lstStyle/>
+          <a:p>
+            <a:pPr algn="ctr">
+              <a:spcAft>
+                <a:spcPts val="0"/>
+              </a:spcAft>
+              <a:defRPr sz="1100" b="0">
+                <a:solidFill>
+                  <a:srgbClr val="5C6672"/>
+                </a:solidFill>
+                <a:latin typeface="Noto Sans CJK KR"/>
+              </a:defRPr>
+            </a:pPr>
+            <a:r>
+              <a:t>다음 실행 슬라이드에서는 이 명령을 직접 입력하고, 방금 말한 확인 결과가 보일 때까지 진행하지 않습니다.</a:t>
             </a:r>
           </a:p>
         </p:txBody>
@@ -11215,7 +12601,7 @@
               </a:defRPr>
             </a:pPr>
             <a:r>
-              <a:t>구현 뒤 실행 2/2: TF 연결을 검사한다</a:t>
+              <a:t>명령어를 코드처럼 읽기 (2/2)</a:t>
             </a:r>
           </a:p>
         </p:txBody>
@@ -11254,7 +12640,7 @@
               </a:defRPr>
             </a:pPr>
             <a:r>
-              <a:t>방금 직접 만든 파일을 실행·검사하며 다음 파일로 넘어갈 기준을 만듭니다.</a:t>
+              <a:t>새 파일을 만들지 않는 모듈도 한 줄씩 뜻과 화면에서 확인할 결과를 먼저 읽습니다.</a:t>
             </a:r>
           </a:p>
         </p:txBody>
@@ -11390,7 +12776,7 @@
               </a:defRPr>
             </a:pPr>
             <a:r>
-              <a:t>현재 단계 실행 2/2    |    현재 폴더 ~/ros2_curri/my_agv_ws    |    현재 터미널</a:t>
+              <a:t>현재 단계 명령 해설    |    현재 폴더 ~/ros2_curri/my_agv_ws    |    현재 터미널</a:t>
             </a:r>
           </a:p>
         </p:txBody>
@@ -11403,8 +12789,8 @@
         </p:nvSpPr>
         <p:spPr>
           <a:xfrm>
-            <a:off x="676656" y="1764792"/>
-            <a:ext cx="1828800" cy="347472"/>
+            <a:off x="694944" y="1664208"/>
+            <a:ext cx="10789920" cy="274320"/>
           </a:xfrm>
           <a:prstGeom prst="rect">
             <a:avLst/>
@@ -11417,72 +12803,33 @@
           </a:bodyPr>
           <a:lstStyle/>
           <a:p>
-            <a:pPr algn="l">
-              <a:spcAft>
-                <a:spcPts val="0"/>
-              </a:spcAft>
-              <a:defRPr sz="1800" b="1">
-                <a:solidFill>
-                  <a:srgbClr val="225B9B"/>
-                </a:solidFill>
-                <a:latin typeface="Noto Sans CJK KR"/>
-              </a:defRPr>
-            </a:pPr>
-            <a:r>
-              <a:t>왜 하는가</a:t>
-            </a:r>
-          </a:p>
-        </p:txBody>
-      </p:sp>
-      <p:sp>
-        <p:nvSpPr>
-          <p:cNvPr id="8" name="TextBox 7"/>
-          <p:cNvSpPr txBox="1"/>
-          <p:nvPr/>
-        </p:nvSpPr>
-        <p:spPr>
-          <a:xfrm>
-            <a:off x="676656" y="2103120"/>
-            <a:ext cx="10789920" cy="512064"/>
-          </a:xfrm>
-          <a:prstGeom prst="rect">
-            <a:avLst/>
-          </a:prstGeom>
-          <a:noFill/>
-        </p:spPr>
-        <p:txBody>
-          <a:bodyPr wrap="square" lIns="73152" rIns="73152" tIns="36576" bIns="36576">
-            <a:spAutoFit/>
-          </a:bodyPr>
-          <a:lstStyle/>
-          <a:p>
-            <a:pPr algn="l">
-              <a:spcAft>
-                <a:spcPts val="0"/>
-              </a:spcAft>
-              <a:defRPr sz="2000" b="0">
-                <a:solidFill>
-                  <a:srgbClr val="122C4E"/>
-                </a:solidFill>
-                <a:latin typeface="Noto Sans CJK KR"/>
-              </a:defRPr>
-            </a:pPr>
-            <a:r>
-              <a:t>frame의 부모·자식과 누락 여부를 파일로 확인한다.</a:t>
-            </a:r>
-          </a:p>
-        </p:txBody>
-      </p:sp>
-      <p:sp>
-        <p:nvSpPr>
-          <p:cNvPr id="9" name="Rounded Rectangle 8"/>
+            <a:pPr algn="ctr">
+              <a:spcAft>
+                <a:spcPts val="0"/>
+              </a:spcAft>
+              <a:defRPr sz="1500" b="1">
+                <a:solidFill>
+                  <a:srgbClr val="DB7E22"/>
+                </a:solidFill>
+                <a:latin typeface="Noto Sans CJK KR"/>
+              </a:defRPr>
+            </a:pPr>
+            <a:r>
+              <a:t>말로 먼저 답해 보세요: 이 명령은 무엇을 시작하고, 성공하면 어디에 무엇이 보일까요?</a:t>
+            </a:r>
+          </a:p>
+        </p:txBody>
+      </p:sp>
+      <p:sp>
+        <p:nvSpPr>
+          <p:cNvPr id="8" name="Rounded Rectangle 7"/>
           <p:cNvSpPr/>
           <p:nvPr/>
         </p:nvSpPr>
         <p:spPr>
           <a:xfrm>
-            <a:off x="676656" y="2871216"/>
-            <a:ext cx="10835640" cy="2331720"/>
+            <a:off x="658368" y="2359152"/>
+            <a:ext cx="4160520" cy="1417320"/>
           </a:xfrm>
           <a:prstGeom prst="roundRect">
             <a:avLst/>
@@ -11518,7 +12865,7 @@
               <a:spcAft>
                 <a:spcPts val="0"/>
               </a:spcAft>
-              <a:defRPr sz="1600" b="0">
+              <a:defRPr sz="1300" b="0">
                 <a:solidFill>
                   <a:srgbClr val="FFFFFF"/>
                 </a:solidFill>
@@ -11528,10 +12875,51 @@
             <a:r>
               <a:t>ros2 run tf2_tools view_frames</a:t>
             </a:r>
-            <a:br/>
-            <a:r>
-              <a:t># frames.pdf 생성 뒤 base_link → lidar_link 연결을 확인</a:t>
-            </a:r>
+          </a:p>
+        </p:txBody>
+      </p:sp>
+      <p:sp>
+        <p:nvSpPr>
+          <p:cNvPr id="9" name="Rounded Rectangle 8"/>
+          <p:cNvSpPr/>
+          <p:nvPr/>
+        </p:nvSpPr>
+        <p:spPr>
+          <a:xfrm>
+            <a:off x="5029200" y="2359152"/>
+            <a:ext cx="6537960" cy="1417320"/>
+          </a:xfrm>
+          <a:prstGeom prst="roundRect">
+            <a:avLst/>
+          </a:prstGeom>
+          <a:solidFill>
+            <a:srgbClr val="F4F7FB"/>
+          </a:solidFill>
+          <a:ln>
+            <a:solidFill>
+              <a:srgbClr val="225B9B"/>
+            </a:solidFill>
+          </a:ln>
+        </p:spPr>
+        <p:style>
+          <a:lnRef idx="1">
+            <a:schemeClr val="accent1"/>
+          </a:lnRef>
+          <a:fillRef idx="3">
+            <a:schemeClr val="accent1"/>
+          </a:fillRef>
+          <a:effectRef idx="2">
+            <a:schemeClr val="accent1"/>
+          </a:effectRef>
+          <a:fontRef idx="minor">
+            <a:schemeClr val="lt1"/>
+          </a:fontRef>
+        </p:style>
+        <p:txBody>
+          <a:bodyPr rtlCol="0" anchor="ctr"/>
+          <a:lstStyle/>
+          <a:p>
+            <a:pPr algn="ctr"/>
           </a:p>
         </p:txBody>
       </p:sp>
@@ -11543,8 +12931,8 @@
         </p:nvSpPr>
         <p:spPr>
           <a:xfrm>
-            <a:off x="768096" y="5468112"/>
-            <a:ext cx="1143000" cy="256032"/>
+            <a:off x="5239512" y="2468880"/>
+            <a:ext cx="594360" cy="219456"/>
           </a:xfrm>
           <a:prstGeom prst="rect">
             <a:avLst/>
@@ -11561,15 +12949,15 @@
               <a:spcAft>
                 <a:spcPts val="0"/>
               </a:spcAft>
-              <a:defRPr sz="1800" b="1">
-                <a:solidFill>
-                  <a:srgbClr val="2A8B5A"/>
-                </a:solidFill>
-                <a:latin typeface="Noto Sans CJK KR"/>
-              </a:defRPr>
-            </a:pPr>
-            <a:r>
-              <a:t>확인</a:t>
+              <a:defRPr sz="1400" b="1">
+                <a:solidFill>
+                  <a:srgbClr val="225B9B"/>
+                </a:solidFill>
+                <a:latin typeface="Noto Sans CJK KR"/>
+              </a:defRPr>
+            </a:pPr>
+            <a:r>
+              <a:t>1.</a:t>
             </a:r>
           </a:p>
         </p:txBody>
@@ -11582,8 +12970,8 @@
         </p:nvSpPr>
         <p:spPr>
           <a:xfrm>
-            <a:off x="768096" y="5742432"/>
-            <a:ext cx="10561320" cy="347472"/>
+            <a:off x="5596128" y="2450592"/>
+            <a:ext cx="5696712" cy="493776"/>
           </a:xfrm>
           <a:prstGeom prst="rect">
             <a:avLst/>
@@ -11600,7 +12988,7 @@
               <a:spcAft>
                 <a:spcPts val="0"/>
               </a:spcAft>
-              <a:defRPr sz="1800" b="0">
+              <a:defRPr sz="1300" b="0">
                 <a:solidFill>
                   <a:srgbClr val="122C4E"/>
                 </a:solidFill>
@@ -11608,7 +12996,85 @@
               </a:defRPr>
             </a:pPr>
             <a:r>
-              <a:t>출력에서 topic·frame·파일 이름 또는 성공 메시지를 찾고, 맞지 않으면 다음 파일로 가지 않습니다.</a:t>
+              <a:t>뜻: 앞 단어는 package, 뒤 단어는 그 package에 등록된 실행 이름입니다.</a:t>
+            </a:r>
+          </a:p>
+        </p:txBody>
+      </p:sp>
+      <p:sp>
+        <p:nvSpPr>
+          <p:cNvPr id="12" name="TextBox 11"/>
+          <p:cNvSpPr txBox="1"/>
+          <p:nvPr/>
+        </p:nvSpPr>
+        <p:spPr>
+          <a:xfrm>
+            <a:off x="5596128" y="3108960"/>
+            <a:ext cx="5696712" cy="457200"/>
+          </a:xfrm>
+          <a:prstGeom prst="rect">
+            <a:avLst/>
+          </a:prstGeom>
+          <a:noFill/>
+        </p:spPr>
+        <p:txBody>
+          <a:bodyPr wrap="square" lIns="73152" rIns="73152" tIns="36576" bIns="36576">
+            <a:spAutoFit/>
+          </a:bodyPr>
+          <a:lstStyle/>
+          <a:p>
+            <a:pPr algn="l">
+              <a:spcAft>
+                <a:spcPts val="0"/>
+              </a:spcAft>
+              <a:defRPr sz="1200" b="0">
+                <a:solidFill>
+                  <a:srgbClr val="2A8B5A"/>
+                </a:solidFill>
+                <a:latin typeface="Noto Sans CJK KR"/>
+              </a:defRPr>
+            </a:pPr>
+            <a:r>
+              <a:t>실행에서: 실행 terminal의 log와 `ros2 node list`에서 node 동작을 확인합니다.</a:t>
+            </a:r>
+          </a:p>
+        </p:txBody>
+      </p:sp>
+      <p:sp>
+        <p:nvSpPr>
+          <p:cNvPr id="13" name="TextBox 12"/>
+          <p:cNvSpPr txBox="1"/>
+          <p:nvPr/>
+        </p:nvSpPr>
+        <p:spPr>
+          <a:xfrm>
+            <a:off x="749808" y="6199632"/>
+            <a:ext cx="10698480" cy="182880"/>
+          </a:xfrm>
+          <a:prstGeom prst="rect">
+            <a:avLst/>
+          </a:prstGeom>
+          <a:noFill/>
+        </p:spPr>
+        <p:txBody>
+          <a:bodyPr wrap="square" lIns="73152" rIns="73152" tIns="36576" bIns="36576">
+            <a:spAutoFit/>
+          </a:bodyPr>
+          <a:lstStyle/>
+          <a:p>
+            <a:pPr algn="ctr">
+              <a:spcAft>
+                <a:spcPts val="0"/>
+              </a:spcAft>
+              <a:defRPr sz="1100" b="0">
+                <a:solidFill>
+                  <a:srgbClr val="5C6672"/>
+                </a:solidFill>
+                <a:latin typeface="Noto Sans CJK KR"/>
+              </a:defRPr>
+            </a:pPr>
+            <a:r>
+              <a:t>다음 실행 슬라이드에서는 이 명령을 직접 입력하고, 방금 말한 확인 결과가 보일 때까지 진행하지 않습니다.</a:t>
             </a:r>
           </a:p>
         </p:txBody>

</xml_diff>